<commit_message>
NSRU slides: refresh deck + tighten Act-1 stat to p=.0002 (complete separation, n=10/10)
</commit_message>
<xml_diff>
--- a/reports/nsru_slides_2026-07-11.pptx
+++ b/reports/nsru_slides_2026-07-11.pptx
@@ -3136,7 +3136,7 @@
               <a:buNone/>
             </a:pPr>
             <a:r>
-              <a:rPr lang="en-US" sz="2800" b="1" dirty="0">
+              <a:rPr lang="en-US" sz="2600" b="1" dirty="0">
                 <a:solidFill>
                   <a:srgbClr val="0F6E56"/>
                 </a:solidFill>
@@ -3144,9 +3144,9 @@
                 <a:ea typeface="Tahoma" pitchFamily="34" charset="-122"/>
                 <a:cs typeface="Tahoma" pitchFamily="34" charset="-120"/>
               </a:rPr>
-              <a:t>p&lt;.001</a:t>
-            </a:r>
-            <a:endParaRPr lang="en-US" sz="2800" dirty="0"/>
+              <a:t>p=.0002</a:t>
+            </a:r>
+            <a:endParaRPr lang="en-US" sz="2600" dirty="0"/>
           </a:p>
         </p:txBody>
       </p:sp>
@@ -3183,7 +3183,7 @@
                 <a:ea typeface="Tahoma" pitchFamily="34" charset="-122"/>
                 <a:cs typeface="Tahoma" pitchFamily="34" charset="-120"/>
               </a:rPr>
-              <a:t>ต่างกันจริง (10 ซีด)</a:t>
+              <a:t>10 ซีด · แยกขาด</a:t>
             </a:r>
             <a:endParaRPr lang="en-US" sz="1200" dirty="0"/>
           </a:p>

</xml_diff>

<commit_message>
Update longevity notes, NSRU deliverables, and study drivers
</commit_message>
<xml_diff>
--- a/reports/nsru_slides_2026-07-11.pptx
+++ b/reports/nsru_slides_2026-07-11.pptx
@@ -1,24 +1,24 @@
 
 <file path=ppt/presentation.xml><?xml version="1.0" encoding="utf-8"?>
-<p:presentation xmlns:a="http://schemas.openxmlformats.org/drawingml/2006/main" xmlns:r="http://schemas.openxmlformats.org/officeDocument/2006/relationships" xmlns:p="http://schemas.openxmlformats.org/presentationml/2006/main" saveSubsetFonts="1" autoCompressPictures="0">
+<p:presentation xmlns:a="http://schemas.openxmlformats.org/drawingml/2006/main" xmlns:r="http://schemas.openxmlformats.org/officeDocument/2006/relationships" xmlns:p="http://schemas.openxmlformats.org/presentationml/2006/main" autoCompressPictures="0">
   <p:sldMasterIdLst>
     <p:sldMasterId id="2147483648" r:id="rId1"/>
   </p:sldMasterIdLst>
+  <p:notesMasterIdLst>
+    <p:notesMasterId r:id="rId4"/>
+  </p:notesMasterIdLst>
   <p:sldIdLst>
-    <p:sldId id="256" r:id="rId2"/>
-    <p:sldId id="257" r:id="rId3"/>
-    <p:sldId id="258" r:id="rId4"/>
-    <p:sldId id="259" r:id="rId5"/>
-    <p:sldId id="260" r:id="rId6"/>
-    <p:sldId id="261" r:id="rId7"/>
-    <p:sldId id="262" r:id="rId8"/>
-    <p:sldId id="263" r:id="rId9"/>
-    <p:sldId id="264" r:id="rId10"/>
-    <p:sldId id="265" r:id="rId11"/>
+    <p:sldId id="256" r:id="rId3"/>
+    <p:sldId id="257" r:id="rId5"/>
+    <p:sldId id="258" r:id="rId6"/>
+    <p:sldId id="259" r:id="rId7"/>
+    <p:sldId id="260" r:id="rId8"/>
+    <p:sldId id="261" r:id="rId9"/>
+    <p:sldId id="262" r:id="rId10"/>
+    <p:sldId id="263" r:id="rId11"/>
+    <p:sldId id="264" r:id="rId12"/>
+    <p:sldId id="265" r:id="rId13"/>
   </p:sldIdLst>
-  <p:notesMasterIdLst>
-    <p:notesMasterId r:id="rId12"/>
-  </p:notesMasterIdLst>
   <p:sldSz cx="12192000" cy="6858000"/>
   <p:notesSz cx="6858000" cy="12192000"/>
   <p:defaultTextStyle>
@@ -198,7 +198,6 @@
           <a:p>
             <a:fld id="{5282F153-3F37-0F45-9E97-73ACFA13230C}" type="datetimeFigureOut">
               <a:rPr lang="en-US"/>
-              <a:t>7/23/19</a:t>
             </a:fld>
             <a:endParaRPr lang="en-US"/>
           </a:p>
@@ -265,6 +264,7 @@
               <a:rPr lang="en-US"/>
               <a:t>Click to edit Master text styles</a:t>
             </a:r>
+            <a:endParaRPr lang="en-US"/>
           </a:p>
           <a:p>
             <a:pPr lvl="1"/>
@@ -272,6 +272,7 @@
               <a:rPr lang="en-US"/>
               <a:t>Second level</a:t>
             </a:r>
+            <a:endParaRPr lang="en-US"/>
           </a:p>
           <a:p>
             <a:pPr lvl="2"/>
@@ -279,6 +280,7 @@
               <a:rPr lang="en-US"/>
               <a:t>Third level</a:t>
             </a:r>
+            <a:endParaRPr lang="en-US"/>
           </a:p>
           <a:p>
             <a:pPr lvl="3"/>
@@ -286,6 +288,7 @@
               <a:rPr lang="en-US"/>
               <a:t>Fourth level</a:t>
             </a:r>
+            <a:endParaRPr lang="en-US"/>
           </a:p>
           <a:p>
             <a:pPr lvl="4"/>
@@ -293,6 +296,7 @@
               <a:rPr lang="en-US"/>
               <a:t>Fifth level</a:t>
             </a:r>
+            <a:endParaRPr lang="en-US"/>
           </a:p>
         </p:txBody>
       </p:sp>
@@ -356,18 +360,12 @@
           <a:p>
             <a:fld id="{CE5E9CC1-C706-0F49-92D6-E571CC5EEA8F}" type="slidenum">
               <a:rPr lang="en-US"/>
-              <a:t>‹#›</a:t>
             </a:fld>
             <a:endParaRPr lang="en-US"/>
           </a:p>
         </p:txBody>
       </p:sp>
     </p:spTree>
-    <p:extLst>
-      <p:ext uri="{BB962C8B-B14F-4D97-AF65-F5344CB8AC3E}">
-        <p14:creationId xmlns:p14="http://schemas.microsoft.com/office/powerpoint/2010/main" val="1024086991"/>
-      </p:ext>
-    </p:extLst>
   </p:cSld>
   <p:clrMap bg1="lt1" tx1="dk1" bg2="lt2" tx2="dk2" accent1="accent1" accent2="accent2" accent3="accent3" accent4="accent4" accent5="accent5" accent6="accent6" hlink="hlink" folHlink="folHlink"/>
   <p:notesStyle>
@@ -534,18 +532,12 @@
           <a:p>
             <a:fld id="{F7021451-1387-4CA6-816F-3879F97B5CBC}" type="slidenum">
               <a:rPr lang="en-US"/>
-              <a:t>1</a:t>
             </a:fld>
             <a:endParaRPr lang="en-US"/>
           </a:p>
         </p:txBody>
       </p:sp>
     </p:spTree>
-    <p:extLst>
-      <p:ext uri="{BB962C8B-B14F-4D97-AF65-F5344CB8AC3E}">
-        <p14:creationId xmlns:p14="http://schemas.microsoft.com/office/powerpoint/2010/main" val="1024086991"/>
-      </p:ext>
-    </p:extLst>
   </p:cSld>
   <p:clrMapOvr>
     <a:masterClrMapping/>
@@ -622,18 +614,12 @@
           <a:p>
             <a:fld id="{F7021451-1387-4CA6-816F-3879F97B5CBC}" type="slidenum">
               <a:rPr lang="en-US"/>
-              <a:t>10</a:t>
             </a:fld>
             <a:endParaRPr lang="en-US"/>
           </a:p>
         </p:txBody>
       </p:sp>
     </p:spTree>
-    <p:extLst>
-      <p:ext uri="{BB962C8B-B14F-4D97-AF65-F5344CB8AC3E}">
-        <p14:creationId xmlns:p14="http://schemas.microsoft.com/office/powerpoint/2010/main" val="1024086991"/>
-      </p:ext>
-    </p:extLst>
   </p:cSld>
   <p:clrMapOvr>
     <a:masterClrMapping/>
@@ -710,18 +696,12 @@
           <a:p>
             <a:fld id="{F7021451-1387-4CA6-816F-3879F97B5CBC}" type="slidenum">
               <a:rPr lang="en-US"/>
-              <a:t>2</a:t>
             </a:fld>
             <a:endParaRPr lang="en-US"/>
           </a:p>
         </p:txBody>
       </p:sp>
     </p:spTree>
-    <p:extLst>
-      <p:ext uri="{BB962C8B-B14F-4D97-AF65-F5344CB8AC3E}">
-        <p14:creationId xmlns:p14="http://schemas.microsoft.com/office/powerpoint/2010/main" val="1024086991"/>
-      </p:ext>
-    </p:extLst>
   </p:cSld>
   <p:clrMapOvr>
     <a:masterClrMapping/>
@@ -798,18 +778,12 @@
           <a:p>
             <a:fld id="{F7021451-1387-4CA6-816F-3879F97B5CBC}" type="slidenum">
               <a:rPr lang="en-US"/>
-              <a:t>3</a:t>
             </a:fld>
             <a:endParaRPr lang="en-US"/>
           </a:p>
         </p:txBody>
       </p:sp>
     </p:spTree>
-    <p:extLst>
-      <p:ext uri="{BB962C8B-B14F-4D97-AF65-F5344CB8AC3E}">
-        <p14:creationId xmlns:p14="http://schemas.microsoft.com/office/powerpoint/2010/main" val="1024086991"/>
-      </p:ext>
-    </p:extLst>
   </p:cSld>
   <p:clrMapOvr>
     <a:masterClrMapping/>
@@ -886,18 +860,12 @@
           <a:p>
             <a:fld id="{F7021451-1387-4CA6-816F-3879F97B5CBC}" type="slidenum">
               <a:rPr lang="en-US"/>
-              <a:t>4</a:t>
             </a:fld>
             <a:endParaRPr lang="en-US"/>
           </a:p>
         </p:txBody>
       </p:sp>
     </p:spTree>
-    <p:extLst>
-      <p:ext uri="{BB962C8B-B14F-4D97-AF65-F5344CB8AC3E}">
-        <p14:creationId xmlns:p14="http://schemas.microsoft.com/office/powerpoint/2010/main" val="1024086991"/>
-      </p:ext>
-    </p:extLst>
   </p:cSld>
   <p:clrMapOvr>
     <a:masterClrMapping/>
@@ -974,18 +942,12 @@
           <a:p>
             <a:fld id="{F7021451-1387-4CA6-816F-3879F97B5CBC}" type="slidenum">
               <a:rPr lang="en-US"/>
-              <a:t>5</a:t>
             </a:fld>
             <a:endParaRPr lang="en-US"/>
           </a:p>
         </p:txBody>
       </p:sp>
     </p:spTree>
-    <p:extLst>
-      <p:ext uri="{BB962C8B-B14F-4D97-AF65-F5344CB8AC3E}">
-        <p14:creationId xmlns:p14="http://schemas.microsoft.com/office/powerpoint/2010/main" val="1024086991"/>
-      </p:ext>
-    </p:extLst>
   </p:cSld>
   <p:clrMapOvr>
     <a:masterClrMapping/>
@@ -1062,18 +1024,12 @@
           <a:p>
             <a:fld id="{F7021451-1387-4CA6-816F-3879F97B5CBC}" type="slidenum">
               <a:rPr lang="en-US"/>
-              <a:t>6</a:t>
             </a:fld>
             <a:endParaRPr lang="en-US"/>
           </a:p>
         </p:txBody>
       </p:sp>
     </p:spTree>
-    <p:extLst>
-      <p:ext uri="{BB962C8B-B14F-4D97-AF65-F5344CB8AC3E}">
-        <p14:creationId xmlns:p14="http://schemas.microsoft.com/office/powerpoint/2010/main" val="1024086991"/>
-      </p:ext>
-    </p:extLst>
   </p:cSld>
   <p:clrMapOvr>
     <a:masterClrMapping/>
@@ -1150,18 +1106,12 @@
           <a:p>
             <a:fld id="{F7021451-1387-4CA6-816F-3879F97B5CBC}" type="slidenum">
               <a:rPr lang="en-US"/>
-              <a:t>7</a:t>
             </a:fld>
             <a:endParaRPr lang="en-US"/>
           </a:p>
         </p:txBody>
       </p:sp>
     </p:spTree>
-    <p:extLst>
-      <p:ext uri="{BB962C8B-B14F-4D97-AF65-F5344CB8AC3E}">
-        <p14:creationId xmlns:p14="http://schemas.microsoft.com/office/powerpoint/2010/main" val="1024086991"/>
-      </p:ext>
-    </p:extLst>
   </p:cSld>
   <p:clrMapOvr>
     <a:masterClrMapping/>
@@ -1238,18 +1188,12 @@
           <a:p>
             <a:fld id="{F7021451-1387-4CA6-816F-3879F97B5CBC}" type="slidenum">
               <a:rPr lang="en-US"/>
-              <a:t>8</a:t>
             </a:fld>
             <a:endParaRPr lang="en-US"/>
           </a:p>
         </p:txBody>
       </p:sp>
     </p:spTree>
-    <p:extLst>
-      <p:ext uri="{BB962C8B-B14F-4D97-AF65-F5344CB8AC3E}">
-        <p14:creationId xmlns:p14="http://schemas.microsoft.com/office/powerpoint/2010/main" val="1024086991"/>
-      </p:ext>
-    </p:extLst>
   </p:cSld>
   <p:clrMapOvr>
     <a:masterClrMapping/>
@@ -1326,18 +1270,12 @@
           <a:p>
             <a:fld id="{F7021451-1387-4CA6-816F-3879F97B5CBC}" type="slidenum">
               <a:rPr lang="en-US"/>
-              <a:t>9</a:t>
             </a:fld>
             <a:endParaRPr lang="en-US"/>
           </a:p>
         </p:txBody>
       </p:sp>
     </p:spTree>
-    <p:extLst>
-      <p:ext uri="{BB962C8B-B14F-4D97-AF65-F5344CB8AC3E}">
-        <p14:creationId xmlns:p14="http://schemas.microsoft.com/office/powerpoint/2010/main" val="1024086991"/>
-      </p:ext>
-    </p:extLst>
   </p:cSld>
   <p:clrMapOvr>
     <a:masterClrMapping/>
@@ -1383,6 +1321,7 @@
         <a:solidFill>
           <a:srgbClr val="FFFFFF"/>
         </a:solidFill>
+        <a:effectLst/>
       </p:bgPr>
     </p:bg>
     <p:spTree>
@@ -1410,6 +1349,11 @@
 <file path=ppt/slideMasters/slideMaster1.xml><?xml version="1.0" encoding="utf-8"?>
 <p:sldMaster xmlns:a="http://schemas.openxmlformats.org/drawingml/2006/main" xmlns:r="http://schemas.openxmlformats.org/officeDocument/2006/relationships" xmlns:p="http://schemas.openxmlformats.org/presentationml/2006/main">
   <p:cSld>
+    <p:bg>
+      <p:bgRef idx="1001">
+        <a:schemeClr val="bg1"/>
+      </p:bgRef>
+    </p:bg>
     <p:spTree>
       <p:nvGrpSpPr>
         <p:cNvPr id="1" name=""/>
@@ -1454,7 +1398,7 @@
         <a:spcBef>
           <a:spcPct val="20000"/>
         </a:spcBef>
-        <a:buFont typeface="Arial" pitchFamily="34" charset="0"/>
+        <a:buFont typeface="Arial" panose="020B0604020202020204" pitchFamily="34" charset="0"/>
         <a:buChar char="•"/>
         <a:defRPr sz="3200" kern="1200">
           <a:solidFill>
@@ -1469,7 +1413,7 @@
         <a:spcBef>
           <a:spcPct val="20000"/>
         </a:spcBef>
-        <a:buFont typeface="Arial" pitchFamily="34" charset="0"/>
+        <a:buFont typeface="Arial" panose="020B0604020202020204" pitchFamily="34" charset="0"/>
         <a:buChar char="–"/>
         <a:defRPr sz="2800" kern="1200">
           <a:solidFill>
@@ -1484,7 +1428,7 @@
         <a:spcBef>
           <a:spcPct val="20000"/>
         </a:spcBef>
-        <a:buFont typeface="Arial" pitchFamily="34" charset="0"/>
+        <a:buFont typeface="Arial" panose="020B0604020202020204" pitchFamily="34" charset="0"/>
         <a:buChar char="•"/>
         <a:defRPr sz="2400" kern="1200">
           <a:solidFill>
@@ -1499,7 +1443,7 @@
         <a:spcBef>
           <a:spcPct val="20000"/>
         </a:spcBef>
-        <a:buFont typeface="Arial" pitchFamily="34" charset="0"/>
+        <a:buFont typeface="Arial" panose="020B0604020202020204" pitchFamily="34" charset="0"/>
         <a:buChar char="–"/>
         <a:defRPr sz="2000" kern="1200">
           <a:solidFill>
@@ -1514,7 +1458,7 @@
         <a:spcBef>
           <a:spcPct val="20000"/>
         </a:spcBef>
-        <a:buFont typeface="Arial" pitchFamily="34" charset="0"/>
+        <a:buFont typeface="Arial" panose="020B0604020202020204" pitchFamily="34" charset="0"/>
         <a:buChar char="»"/>
         <a:defRPr sz="2000" kern="1200">
           <a:solidFill>
@@ -1529,7 +1473,7 @@
         <a:spcBef>
           <a:spcPct val="20000"/>
         </a:spcBef>
-        <a:buFont typeface="Arial" pitchFamily="34" charset="0"/>
+        <a:buFont typeface="Arial" panose="020B0604020202020204" pitchFamily="34" charset="0"/>
         <a:buChar char="•"/>
         <a:defRPr sz="2000" kern="1200">
           <a:solidFill>
@@ -1544,7 +1488,7 @@
         <a:spcBef>
           <a:spcPct val="20000"/>
         </a:spcBef>
-        <a:buFont typeface="Arial" pitchFamily="34" charset="0"/>
+        <a:buFont typeface="Arial" panose="020B0604020202020204" pitchFamily="34" charset="0"/>
         <a:buChar char="•"/>
         <a:defRPr sz="2000" kern="1200">
           <a:solidFill>
@@ -1559,7 +1503,7 @@
         <a:spcBef>
           <a:spcPct val="20000"/>
         </a:spcBef>
-        <a:buFont typeface="Arial" pitchFamily="34" charset="0"/>
+        <a:buFont typeface="Arial" panose="020B0604020202020204" pitchFamily="34" charset="0"/>
         <a:buChar char="•"/>
         <a:defRPr sz="2000" kern="1200">
           <a:solidFill>
@@ -1574,7 +1518,7 @@
         <a:spcBef>
           <a:spcPct val="20000"/>
         </a:spcBef>
-        <a:buFont typeface="Arial" pitchFamily="34" charset="0"/>
+        <a:buFont typeface="Arial" panose="020B0604020202020204" pitchFamily="34" charset="0"/>
         <a:buChar char="•"/>
         <a:defRPr sz="2000" kern="1200">
           <a:solidFill>
@@ -1687,12 +1631,13 @@
 
 <file path=ppt/slides/slide1.xml><?xml version="1.0" encoding="utf-8"?>
 <p:sld xmlns:a="http://schemas.openxmlformats.org/drawingml/2006/main" xmlns:r="http://schemas.openxmlformats.org/officeDocument/2006/relationships" xmlns:p="http://schemas.openxmlformats.org/presentationml/2006/main">
-  <p:cSld name="Slide 1">
+  <p:cSld>
     <p:bg>
       <p:bgPr>
         <a:solidFill>
           <a:srgbClr val="13312C"/>
         </a:solidFill>
+        <a:effectLst/>
       </p:bgPr>
     </p:bg>
     <p:spTree>
@@ -1724,13 +1669,12 @@
             <a:avLst/>
           </a:prstGeom>
           <a:noFill/>
-          <a:ln/>
         </p:spPr>
         <p:txBody>
           <a:bodyPr wrap="square" lIns="0" tIns="0" rIns="0" bIns="0" rtlCol="0" anchor="ctr"/>
           <a:lstStyle/>
           <a:p>
-            <a:pPr algn="l" indent="0" marL="0">
+            <a:pPr marL="0" indent="0" algn="l">
               <a:buNone/>
             </a:pPr>
             <a:r>
@@ -1738,9 +1682,9 @@
                 <a:solidFill>
                   <a:srgbClr val="B7791F"/>
                 </a:solidFill>
-                <a:latin typeface="Tahoma" pitchFamily="34" charset="0"/>
-                <a:ea typeface="Tahoma" pitchFamily="34" charset="-122"/>
-                <a:cs typeface="Tahoma" pitchFamily="34" charset="-120"/>
+                <a:latin typeface="Tahoma" panose="020B0604030504040204" pitchFamily="34" charset="0"/>
+                <a:ea typeface="Tahoma" panose="020B0604030504040204" pitchFamily="34" charset="-122"/>
+                <a:cs typeface="Tahoma" panose="020B0604030504040204" pitchFamily="34" charset="-120"/>
               </a:rPr>
               <a:t>กับดักพิษแปรผัน</a:t>
             </a:r>
@@ -1763,13 +1707,12 @@
             <a:avLst/>
           </a:prstGeom>
           <a:noFill/>
-          <a:ln/>
         </p:spPr>
         <p:txBody>
           <a:bodyPr wrap="square" lIns="0" tIns="0" rIns="0" bIns="0" rtlCol="0" anchor="t"/>
           <a:lstStyle/>
           <a:p>
-            <a:pPr algn="l" indent="0" marL="0">
+            <a:pPr marL="0" indent="0" algn="l">
               <a:buNone/>
             </a:pPr>
             <a:r>
@@ -1777,11 +1720,32 @@
                 <a:solidFill>
                   <a:srgbClr val="FFFFFF"/>
                 </a:solidFill>
-                <a:latin typeface="Tahoma" pitchFamily="34" charset="0"/>
-                <a:ea typeface="Tahoma" pitchFamily="34" charset="-122"/>
-                <a:cs typeface="Tahoma" pitchFamily="34" charset="-120"/>
-              </a:rPr>
-              <a:t>การศึกษาพฤติกรรมการเรียนรู้เพื่อหลีกเลี่ยงอันตรายของปัญญาประดิษฐ์ในสภาพแวดล้อมจำลอง</a:t>
+                <a:latin typeface="Tahoma" panose="020B0604030504040204" pitchFamily="34" charset="0"/>
+                <a:ea typeface="Tahoma" panose="020B0604030504040204" pitchFamily="34" charset="-122"/>
+                <a:cs typeface="Tahoma" panose="020B0604030504040204" pitchFamily="34" charset="-120"/>
+              </a:rPr>
+              <a:t>การศึกษาพฤติกรรมการเรียนรู้เพื่อหลีกเลี่ยงอันตรายของ</a:t>
+            </a:r>
+            <a:br>
+              <a:rPr lang="en-US" sz="2000" b="1" dirty="0">
+                <a:solidFill>
+                  <a:srgbClr val="FFFFFF"/>
+                </a:solidFill>
+                <a:latin typeface="Tahoma" panose="020B0604030504040204" pitchFamily="34" charset="0"/>
+                <a:ea typeface="Tahoma" panose="020B0604030504040204" pitchFamily="34" charset="-122"/>
+                <a:cs typeface="Tahoma" panose="020B0604030504040204" pitchFamily="34" charset="-120"/>
+              </a:rPr>
+            </a:br>
+            <a:r>
+              <a:rPr lang="en-US" sz="2000" b="1" dirty="0">
+                <a:solidFill>
+                  <a:srgbClr val="FFFFFF"/>
+                </a:solidFill>
+                <a:latin typeface="Tahoma" panose="020B0604030504040204" pitchFamily="34" charset="0"/>
+                <a:ea typeface="Tahoma" panose="020B0604030504040204" pitchFamily="34" charset="-122"/>
+                <a:cs typeface="Tahoma" panose="020B0604030504040204" pitchFamily="34" charset="-120"/>
+              </a:rPr>
+              <a:t>ปัญญาประดิษฐ์ในสภาพแวดล้อมจำลอง</a:t>
             </a:r>
             <a:endParaRPr lang="en-US" sz="2000" dirty="0"/>
           </a:p>
@@ -1802,13 +1766,12 @@
             <a:avLst/>
           </a:prstGeom>
           <a:noFill/>
-          <a:ln/>
         </p:spPr>
         <p:txBody>
           <a:bodyPr wrap="square" lIns="0" tIns="0" rIns="0" bIns="0" rtlCol="0" anchor="ctr"/>
           <a:lstStyle/>
           <a:p>
-            <a:pPr algn="l" indent="0" marL="0">
+            <a:pPr marL="0" indent="0" algn="l">
               <a:buNone/>
             </a:pPr>
             <a:r>
@@ -1816,9 +1779,9 @@
                 <a:solidFill>
                   <a:srgbClr val="AFC6BD"/>
                 </a:solidFill>
-                <a:latin typeface="Tahoma" pitchFamily="34" charset="0"/>
-                <a:ea typeface="Tahoma" pitchFamily="34" charset="-122"/>
-                <a:cs typeface="Tahoma" pitchFamily="34" charset="-120"/>
+                <a:latin typeface="Tahoma" panose="020B0604030504040204" pitchFamily="34" charset="0"/>
+                <a:ea typeface="Tahoma" panose="020B0604030504040204" pitchFamily="34" charset="-122"/>
+                <a:cs typeface="Tahoma" panose="020B0604030504040204" pitchFamily="34" charset="-120"/>
               </a:rPr>
               <a:t>บทเรียนความปลอดภัยของ AI ในโลกที่อันตรายเปลี่ยนตามเวลา</a:t>
             </a:r>
@@ -1841,13 +1804,12 @@
             <a:avLst/>
           </a:prstGeom>
           <a:noFill/>
-          <a:ln/>
         </p:spPr>
         <p:txBody>
           <a:bodyPr wrap="square" lIns="0" tIns="0" rIns="0" bIns="0" rtlCol="0" anchor="ctr"/>
           <a:lstStyle/>
           <a:p>
-            <a:pPr algn="l" indent="0" marL="0">
+            <a:pPr marL="0" indent="0" algn="l">
               <a:buNone/>
             </a:pPr>
             <a:r>
@@ -1855,16 +1817,16 @@
                 <a:solidFill>
                   <a:srgbClr val="FFFFFF"/>
                 </a:solidFill>
-                <a:latin typeface="Tahoma" pitchFamily="34" charset="0"/>
-                <a:ea typeface="Tahoma" pitchFamily="34" charset="-122"/>
-                <a:cs typeface="Tahoma" pitchFamily="34" charset="-120"/>
+                <a:latin typeface="Tahoma" panose="020B0604030504040204" pitchFamily="34" charset="0"/>
+                <a:ea typeface="Tahoma" panose="020B0604030504040204" pitchFamily="34" charset="-122"/>
+                <a:cs typeface="Tahoma" panose="020B0604030504040204" pitchFamily="34" charset="-120"/>
               </a:rPr>
               <a:t>นายชิษณุพงศ์ อินทร์จันทร์</a:t>
             </a:r>
             <a:endParaRPr lang="en-US" sz="1600" dirty="0"/>
           </a:p>
           <a:p>
-            <a:pPr algn="l" indent="0" marL="0">
+            <a:pPr marL="0" indent="0" algn="l">
               <a:buNone/>
             </a:pPr>
             <a:r>
@@ -1872,9 +1834,9 @@
                 <a:solidFill>
                   <a:srgbClr val="CFE3DA"/>
                 </a:solidFill>
-                <a:latin typeface="Tahoma" pitchFamily="34" charset="0"/>
-                <a:ea typeface="Tahoma" pitchFamily="34" charset="-122"/>
-                <a:cs typeface="Tahoma" pitchFamily="34" charset="-120"/>
+                <a:latin typeface="Tahoma" panose="020B0604030504040204" pitchFamily="34" charset="0"/>
+                <a:ea typeface="Tahoma" panose="020B0604030504040204" pitchFamily="34" charset="-122"/>
+                <a:cs typeface="Tahoma" panose="020B0604030504040204" pitchFamily="34" charset="-120"/>
               </a:rPr>
               <a:t>โรงเรียนดีบุกพังงาวิทยายน</a:t>
             </a:r>
@@ -1899,9 +1861,8 @@
           <a:solidFill>
             <a:srgbClr val="B2352E"/>
           </a:solidFill>
-          <a:ln/>
           <a:effectLst>
-            <a:outerShdw sx="100000" sy="100000" kx="0" ky="0" algn="bl" rotWithShape="0" blurRad="76200" dist="25400" dir="5400000">
+            <a:outerShdw blurRad="76200" dist="25400" dir="5400000" algn="bl" rotWithShape="0">
               <a:srgbClr val="9AA6A2">
                 <a:alpha val="35000"/>
               </a:srgbClr>
@@ -1924,13 +1885,12 @@
             <a:avLst/>
           </a:prstGeom>
           <a:noFill/>
-          <a:ln/>
         </p:spPr>
         <p:txBody>
           <a:bodyPr wrap="square" lIns="0" tIns="0" rIns="0" bIns="0" rtlCol="0" anchor="ctr"/>
           <a:lstStyle/>
           <a:p>
-            <a:pPr algn="ctr" indent="0" marL="0">
+            <a:pPr marL="0" indent="0" algn="ctr">
               <a:buNone/>
             </a:pPr>
             <a:r>
@@ -1938,16 +1898,16 @@
                 <a:solidFill>
                   <a:srgbClr val="FFFFFF"/>
                 </a:solidFill>
-                <a:latin typeface="Tahoma" pitchFamily="34" charset="0"/>
-                <a:ea typeface="Tahoma" pitchFamily="34" charset="-122"/>
-                <a:cs typeface="Tahoma" pitchFamily="34" charset="-120"/>
+                <a:latin typeface="Tahoma" panose="020B0604030504040204" pitchFamily="34" charset="0"/>
+                <a:ea typeface="Tahoma" panose="020B0604030504040204" pitchFamily="34" charset="-122"/>
+                <a:cs typeface="Tahoma" panose="020B0604030504040204" pitchFamily="34" charset="-120"/>
               </a:rPr>
               <a:t>63–99%</a:t>
             </a:r>
             <a:endParaRPr lang="en-US" sz="4400" dirty="0"/>
           </a:p>
           <a:p>
-            <a:pPr algn="ctr" indent="0" marL="0">
+            <a:pPr marL="0" indent="0" algn="ctr">
               <a:buNone/>
             </a:pPr>
             <a:r>
@@ -1955,16 +1915,16 @@
                 <a:solidFill>
                   <a:srgbClr val="FBE3E0"/>
                 </a:solidFill>
-                <a:latin typeface="Tahoma" pitchFamily="34" charset="0"/>
-                <a:ea typeface="Tahoma" pitchFamily="34" charset="-122"/>
-                <a:cs typeface="Tahoma" pitchFamily="34" charset="-120"/>
+                <a:latin typeface="Tahoma" panose="020B0604030504040204" pitchFamily="34" charset="0"/>
+                <a:ea typeface="Tahoma" panose="020B0604030504040204" pitchFamily="34" charset="-122"/>
+                <a:cs typeface="Tahoma" panose="020B0604030504040204" pitchFamily="34" charset="-120"/>
               </a:rPr>
               <a:t>AI ถูกหลอกให้จัด</a:t>
             </a:r>
             <a:endParaRPr lang="en-US" sz="4400" dirty="0"/>
           </a:p>
           <a:p>
-            <a:pPr algn="ctr" indent="0" marL="0">
+            <a:pPr marL="0" indent="0" algn="ctr">
               <a:buNone/>
             </a:pPr>
             <a:r>
@@ -1972,9 +1932,9 @@
                 <a:solidFill>
                   <a:srgbClr val="FBE3E0"/>
                 </a:solidFill>
-                <a:latin typeface="Tahoma" pitchFamily="34" charset="0"/>
-                <a:ea typeface="Tahoma" pitchFamily="34" charset="-122"/>
-                <a:cs typeface="Tahoma" pitchFamily="34" charset="-120"/>
+                <a:latin typeface="Tahoma" panose="020B0604030504040204" pitchFamily="34" charset="0"/>
+                <a:ea typeface="Tahoma" panose="020B0604030504040204" pitchFamily="34" charset="-122"/>
+                <a:cs typeface="Tahoma" panose="020B0604030504040204" pitchFamily="34" charset="-120"/>
               </a:rPr>
               <a:t>พิษเป็นอาหารดีที่สุด</a:t>
             </a:r>
@@ -1992,12 +1952,13 @@
 
 <file path=ppt/slides/slide10.xml><?xml version="1.0" encoding="utf-8"?>
 <p:sld xmlns:a="http://schemas.openxmlformats.org/drawingml/2006/main" xmlns:r="http://schemas.openxmlformats.org/officeDocument/2006/relationships" xmlns:p="http://schemas.openxmlformats.org/presentationml/2006/main">
-  <p:cSld name="Slide 10">
+  <p:cSld>
     <p:bg>
       <p:bgPr>
         <a:solidFill>
           <a:srgbClr val="13312C"/>
         </a:solidFill>
+        <a:effectLst/>
       </p:bgPr>
     </p:bg>
     <p:spTree>
@@ -2029,13 +1990,12 @@
             <a:avLst/>
           </a:prstGeom>
           <a:noFill/>
-          <a:ln/>
         </p:spPr>
         <p:txBody>
           <a:bodyPr wrap="square" lIns="0" tIns="0" rIns="0" bIns="0" rtlCol="0" anchor="ctr"/>
           <a:lstStyle/>
           <a:p>
-            <a:pPr algn="l" indent="0" marL="0">
+            <a:pPr marL="0" indent="0" algn="l">
               <a:buNone/>
             </a:pPr>
             <a:r>
@@ -2043,9 +2003,9 @@
                 <a:solidFill>
                   <a:srgbClr val="B7791F"/>
                 </a:solidFill>
-                <a:latin typeface="Tahoma" pitchFamily="34" charset="0"/>
-                <a:ea typeface="Tahoma" pitchFamily="34" charset="-122"/>
-                <a:cs typeface="Tahoma" pitchFamily="34" charset="-120"/>
+                <a:latin typeface="Tahoma" panose="020B0604030504040204" pitchFamily="34" charset="0"/>
+                <a:ea typeface="Tahoma" panose="020B0604030504040204" pitchFamily="34" charset="-122"/>
+                <a:cs typeface="Tahoma" panose="020B0604030504040204" pitchFamily="34" charset="-120"/>
               </a:rPr>
               <a:t>สรุป</a:t>
             </a:r>
@@ -2068,13 +2028,12 @@
             <a:avLst/>
           </a:prstGeom>
           <a:noFill/>
-          <a:ln/>
         </p:spPr>
         <p:txBody>
           <a:bodyPr wrap="square" lIns="0" tIns="0" rIns="0" bIns="0" rtlCol="0" anchor="t"/>
           <a:lstStyle/>
           <a:p>
-            <a:pPr algn="l" indent="0" marL="0">
+            <a:pPr marL="0" indent="0" algn="l">
               <a:spcAft>
                 <a:spcPts val="1000"/>
               </a:spcAft>
@@ -2085,16 +2044,16 @@
                 <a:solidFill>
                   <a:srgbClr val="FFFFFF"/>
                 </a:solidFill>
-                <a:latin typeface="Tahoma" pitchFamily="34" charset="0"/>
-                <a:ea typeface="Tahoma" pitchFamily="34" charset="-122"/>
-                <a:cs typeface="Tahoma" pitchFamily="34" charset="-120"/>
+                <a:latin typeface="Tahoma" panose="020B0604030504040204" pitchFamily="34" charset="0"/>
+                <a:ea typeface="Tahoma" panose="020B0604030504040204" pitchFamily="34" charset="-122"/>
+                <a:cs typeface="Tahoma" panose="020B0604030504040204" pitchFamily="34" charset="-120"/>
               </a:rPr>
               <a:t>ปัญญาประดิษฐ์เรียนรู้เองได้จริงโดยไม่ต้องมีป้าย </a:t>
             </a:r>
             <a:endParaRPr lang="en-US" sz="2200" dirty="0"/>
           </a:p>
           <a:p>
-            <a:pPr algn="l" indent="0" marL="0">
+            <a:pPr marL="0" indent="0" algn="l">
               <a:spcAft>
                 <a:spcPts val="1000"/>
               </a:spcAft>
@@ -2105,54 +2064,21 @@
                 <a:solidFill>
                   <a:srgbClr val="FBE3E0"/>
                 </a:solidFill>
-                <a:latin typeface="Tahoma" pitchFamily="34" charset="0"/>
-                <a:ea typeface="Tahoma" pitchFamily="34" charset="-122"/>
-                <a:cs typeface="Tahoma" pitchFamily="34" charset="-120"/>
+                <a:latin typeface="Tahoma" panose="020B0604030504040204" pitchFamily="34" charset="0"/>
+                <a:ea typeface="Tahoma" panose="020B0604030504040204" pitchFamily="34" charset="-122"/>
+                <a:cs typeface="Tahoma" panose="020B0604030504040204" pitchFamily="34" charset="-120"/>
               </a:rPr>
               <a:t>แต่เมื่ออันตรายเปลี่ยนตามเวลา มันถูกหลอกให้ไล่ล่าอันตรายได้ (สูงถึง 99%)</a:t>
             </a:r>
             <a:endParaRPr lang="en-US" sz="2200" dirty="0"/>
           </a:p>
           <a:p>
-            <a:pPr algn="l" indent="0" marL="0">
+            <a:pPr marL="0" indent="0" algn="l">
               <a:buNone/>
             </a:pPr>
-            <a:r>
-              <a:rPr lang="en-US" sz="2200" b="1" dirty="0">
-                <a:solidFill>
-                  <a:srgbClr val="CFE3DA"/>
-                </a:solidFill>
-                <a:latin typeface="Tahoma" pitchFamily="34" charset="0"/>
-                <a:ea typeface="Tahoma" pitchFamily="34" charset="-122"/>
-                <a:cs typeface="Tahoma" pitchFamily="34" charset="-120"/>
-              </a:rPr>
-              <a:t>ทางแก้: ให้ AI รับรู้ "สัญญาณบอกสภาพ" (เช่น ความสด) ไม่ใช่ปักป้ายทุกอย่าง</a:t>
-            </a:r>
             <a:endParaRPr lang="en-US" sz="2200" dirty="0"/>
           </a:p>
         </p:txBody>
-      </p:sp>
-      <p:sp>
-        <p:nvSpPr>
-          <p:cNvPr id="4" name="Shape 2"/>
-          <p:cNvSpPr/>
-          <p:nvPr/>
-        </p:nvSpPr>
-        <p:spPr>
-          <a:xfrm>
-            <a:off x="548640" y="4114800"/>
-            <a:ext cx="11064240" cy="1188720"/>
-          </a:xfrm>
-          <a:prstGeom prst="roundRect">
-            <a:avLst>
-              <a:gd name="adj" fmla="val 7692"/>
-            </a:avLst>
-          </a:prstGeom>
-          <a:solidFill>
-            <a:srgbClr val="1E4A40"/>
-          </a:solidFill>
-          <a:ln/>
-        </p:spPr>
       </p:sp>
       <p:sp>
         <p:nvSpPr>
@@ -2169,40 +2095,14 @@
             <a:avLst/>
           </a:prstGeom>
           <a:noFill/>
-          <a:ln/>
         </p:spPr>
         <p:txBody>
           <a:bodyPr wrap="square" lIns="0" tIns="0" rIns="0" bIns="0" rtlCol="0" anchor="ctr"/>
           <a:lstStyle/>
           <a:p>
-            <a:pPr algn="l" indent="0" marL="0">
+            <a:pPr marL="0" indent="0" algn="l">
               <a:buNone/>
             </a:pPr>
-            <a:r>
-              <a:rPr lang="en-US" sz="1700" b="1" dirty="0">
-                <a:solidFill>
-                  <a:srgbClr val="B7791F"/>
-                </a:solidFill>
-                <a:latin typeface="Tahoma" pitchFamily="34" charset="0"/>
-                <a:ea typeface="Tahoma" pitchFamily="34" charset="-122"/>
-                <a:cs typeface="Tahoma" pitchFamily="34" charset="-120"/>
-              </a:rPr>
-              <a:t>งานต่อไป: </a:t>
-            </a:r>
-            <a:pPr algn="l" indent="0" marL="0">
-              <a:buNone/>
-            </a:pPr>
-            <a:r>
-              <a:rPr lang="en-US" sz="1700" dirty="0">
-                <a:solidFill>
-                  <a:srgbClr val="FFFFFF"/>
-                </a:solidFill>
-                <a:latin typeface="Tahoma" pitchFamily="34" charset="0"/>
-                <a:ea typeface="Tahoma" pitchFamily="34" charset="-122"/>
-                <a:cs typeface="Tahoma" pitchFamily="34" charset="-120"/>
-              </a:rPr>
-              <a:t>ทดสอบว่า AI จะเรียนที่จะ "เก็บอาหารไว้ให้หายพิษก่อนกิน" ได้เองไหม (store-to-detoxify)</a:t>
-            </a:r>
             <a:endParaRPr lang="en-US" sz="1700" dirty="0"/>
           </a:p>
         </p:txBody>
@@ -2222,13 +2122,12 @@
             <a:avLst/>
           </a:prstGeom>
           <a:noFill/>
-          <a:ln/>
         </p:spPr>
         <p:txBody>
           <a:bodyPr wrap="square" lIns="0" tIns="0" rIns="0" bIns="0" rtlCol="0" anchor="ctr"/>
           <a:lstStyle/>
           <a:p>
-            <a:pPr algn="l" indent="0" marL="0">
+            <a:pPr marL="0" indent="0" algn="l">
               <a:buNone/>
             </a:pPr>
             <a:r>
@@ -2236,9 +2135,9 @@
                 <a:solidFill>
                   <a:srgbClr val="AFC6BD"/>
                 </a:solidFill>
-                <a:latin typeface="Tahoma" pitchFamily="34" charset="0"/>
-                <a:ea typeface="Tahoma" pitchFamily="34" charset="-122"/>
-                <a:cs typeface="Tahoma" pitchFamily="34" charset="-120"/>
+                <a:latin typeface="Tahoma" panose="020B0604030504040204" pitchFamily="34" charset="0"/>
+                <a:ea typeface="Tahoma" panose="020B0604030504040204" pitchFamily="34" charset="-122"/>
+                <a:cs typeface="Tahoma" panose="020B0604030504040204" pitchFamily="34" charset="-120"/>
               </a:rPr>
               <a:t>ขอบคุณครับ — นายชิษณุพงศ์ อินทร์จันทร์ · โรงเรียนดีบุกพังงาวิทยายน</a:t>
             </a:r>
@@ -2256,7 +2155,7 @@
 
 <file path=ppt/slides/slide2.xml><?xml version="1.0" encoding="utf-8"?>
 <p:sld xmlns:a="http://schemas.openxmlformats.org/drawingml/2006/main" xmlns:r="http://schemas.openxmlformats.org/officeDocument/2006/relationships" xmlns:p="http://schemas.openxmlformats.org/presentationml/2006/main">
-  <p:cSld name="Slide 2">
+  <p:cSld>
     <p:spTree>
       <p:nvGrpSpPr>
         <p:cNvPr id="1" name=""/>
@@ -2288,7 +2187,6 @@
           <a:solidFill>
             <a:srgbClr val="0F6E56"/>
           </a:solidFill>
-          <a:ln/>
         </p:spPr>
       </p:sp>
       <p:sp>
@@ -2306,13 +2204,12 @@
             <a:avLst/>
           </a:prstGeom>
           <a:noFill/>
-          <a:ln/>
         </p:spPr>
         <p:txBody>
           <a:bodyPr wrap="square" lIns="0" tIns="0" rIns="0" bIns="0" rtlCol="0" anchor="ctr"/>
           <a:lstStyle/>
           <a:p>
-            <a:pPr algn="ctr" indent="0" marL="0">
+            <a:pPr marL="0" indent="0" algn="ctr">
               <a:buNone/>
             </a:pPr>
             <a:r>
@@ -2320,9 +2217,9 @@
                 <a:solidFill>
                   <a:srgbClr val="FFFFFF"/>
                 </a:solidFill>
-                <a:latin typeface="Tahoma" pitchFamily="34" charset="0"/>
-                <a:ea typeface="Tahoma" pitchFamily="34" charset="-122"/>
-                <a:cs typeface="Tahoma" pitchFamily="34" charset="-120"/>
+                <a:latin typeface="Tahoma" panose="020B0604030504040204" pitchFamily="34" charset="0"/>
+                <a:ea typeface="Tahoma" panose="020B0604030504040204" pitchFamily="34" charset="-122"/>
+                <a:cs typeface="Tahoma" panose="020B0604030504040204" pitchFamily="34" charset="-120"/>
               </a:rPr>
               <a:t>1</a:t>
             </a:r>
@@ -2345,13 +2242,12 @@
             <a:avLst/>
           </a:prstGeom>
           <a:noFill/>
-          <a:ln/>
         </p:spPr>
         <p:txBody>
           <a:bodyPr wrap="square" lIns="0" tIns="0" rIns="0" bIns="0" rtlCol="0" anchor="ctr"/>
           <a:lstStyle/>
           <a:p>
-            <a:pPr algn="l" indent="0" marL="0">
+            <a:pPr marL="0" indent="0" algn="l">
               <a:buNone/>
             </a:pPr>
             <a:r>
@@ -2359,9 +2255,9 @@
                 <a:solidFill>
                   <a:srgbClr val="22302E"/>
                 </a:solidFill>
-                <a:latin typeface="Tahoma" pitchFamily="34" charset="0"/>
-                <a:ea typeface="Tahoma" pitchFamily="34" charset="-122"/>
-                <a:cs typeface="Tahoma" pitchFamily="34" charset="-120"/>
+                <a:latin typeface="Tahoma" panose="020B0604030504040204" pitchFamily="34" charset="0"/>
+                <a:ea typeface="Tahoma" panose="020B0604030504040204" pitchFamily="34" charset="-122"/>
+                <a:cs typeface="Tahoma" panose="020B0604030504040204" pitchFamily="34" charset="-120"/>
               </a:rPr>
               <a:t>ทำไมต้องเรียนเองโดยไม่มีป้าย?</a:t>
             </a:r>
@@ -2384,13 +2280,12 @@
             <a:avLst/>
           </a:prstGeom>
           <a:noFill/>
-          <a:ln/>
         </p:spPr>
         <p:txBody>
           <a:bodyPr wrap="square" lIns="0" tIns="0" rIns="0" bIns="0" rtlCol="0" anchor="t"/>
           <a:lstStyle/>
           <a:p>
-            <a:pPr algn="l" marL="177800" indent="-177800">
+            <a:pPr marL="177800" indent="-177800" algn="l">
               <a:spcAft>
                 <a:spcPts val="800"/>
               </a:spcAft>
@@ -2402,16 +2297,16 @@
                 <a:solidFill>
                   <a:srgbClr val="22302E"/>
                 </a:solidFill>
-                <a:latin typeface="Tahoma" pitchFamily="34" charset="0"/>
-                <a:ea typeface="Tahoma" pitchFamily="34" charset="-122"/>
-                <a:cs typeface="Tahoma" pitchFamily="34" charset="-120"/>
+                <a:latin typeface="Tahoma" panose="020B0604030504040204" pitchFamily="34" charset="0"/>
+                <a:ea typeface="Tahoma" panose="020B0604030504040204" pitchFamily="34" charset="-122"/>
+                <a:cs typeface="Tahoma" panose="020B0604030504040204" pitchFamily="34" charset="-120"/>
               </a:rPr>
               <a:t>AI ที่เก่งที่สุดวันนี้ (เช่น GPT) เก่งเพราะมนุษย์ "ปักป้าย" ข้อมูลให้ล่วงหน้า</a:t>
             </a:r>
             <a:endParaRPr lang="en-US" sz="1700" dirty="0"/>
           </a:p>
           <a:p>
-            <a:pPr algn="l" marL="177800" indent="-177800">
+            <a:pPr marL="177800" indent="-177800" algn="l">
               <a:spcAft>
                 <a:spcPts val="800"/>
               </a:spcAft>
@@ -2423,16 +2318,16 @@
                 <a:solidFill>
                   <a:srgbClr val="22302E"/>
                 </a:solidFill>
-                <a:latin typeface="Tahoma" pitchFamily="34" charset="0"/>
-                <a:ea typeface="Tahoma" pitchFamily="34" charset="-122"/>
-                <a:cs typeface="Tahoma" pitchFamily="34" charset="-120"/>
+                <a:latin typeface="Tahoma" panose="020B0604030504040204" pitchFamily="34" charset="0"/>
+                <a:ea typeface="Tahoma" panose="020B0604030504040204" pitchFamily="34" charset="-122"/>
+                <a:cs typeface="Tahoma" panose="020B0604030504040204" pitchFamily="34" charset="-120"/>
               </a:rPr>
               <a:t>แต่ในโลกจริงหลายที่ มนุษย์เองก็ปักป้ายให้ไม่ได้ (พื้นที่ภัยพิบัติ ใต้ทะเล ดาวดวงอื่น)</a:t>
             </a:r>
             <a:endParaRPr lang="en-US" sz="1700" dirty="0"/>
           </a:p>
           <a:p>
-            <a:pPr algn="l" marL="177800" indent="-177800">
+            <a:pPr marL="177800" indent="-177800" algn="l">
               <a:spcAft>
                 <a:spcPts val="800"/>
               </a:spcAft>
@@ -2444,16 +2339,16 @@
                 <a:solidFill>
                   <a:srgbClr val="22302E"/>
                 </a:solidFill>
-                <a:latin typeface="Tahoma" pitchFamily="34" charset="0"/>
-                <a:ea typeface="Tahoma" pitchFamily="34" charset="-122"/>
-                <a:cs typeface="Tahoma" pitchFamily="34" charset="-120"/>
+                <a:latin typeface="Tahoma" panose="020B0604030504040204" pitchFamily="34" charset="0"/>
+                <a:ea typeface="Tahoma" panose="020B0604030504040204" pitchFamily="34" charset="-122"/>
+                <a:cs typeface="Tahoma" panose="020B0604030504040204" pitchFamily="34" charset="-120"/>
               </a:rPr>
               <a:t>ยิ่งกว่านั้น อันตรายมัก "เปลี่ยนตามเวลา" — ผลไม้ดิบมีพิษ พอสุกกินได้ เน่าเป็นพิษ</a:t>
             </a:r>
             <a:endParaRPr lang="en-US" sz="1700" dirty="0"/>
           </a:p>
           <a:p>
-            <a:pPr algn="l" marL="177800" indent="-177800">
+            <a:pPr marL="177800" indent="-177800" algn="l">
               <a:spcAft>
                 <a:spcPts val="800"/>
               </a:spcAft>
@@ -2465,9 +2360,9 @@
                 <a:solidFill>
                   <a:srgbClr val="22302E"/>
                 </a:solidFill>
-                <a:latin typeface="Tahoma" pitchFamily="34" charset="0"/>
-                <a:ea typeface="Tahoma" pitchFamily="34" charset="-122"/>
-                <a:cs typeface="Tahoma" pitchFamily="34" charset="-120"/>
+                <a:latin typeface="Tahoma" panose="020B0604030504040204" pitchFamily="34" charset="0"/>
+                <a:ea typeface="Tahoma" panose="020B0604030504040204" pitchFamily="34" charset="-122"/>
+                <a:cs typeface="Tahoma" panose="020B0604030504040204" pitchFamily="34" charset="-120"/>
               </a:rPr>
               <a:t>ใกล้ตัว: เห็ดป่าพิษที่คนไทยเก็บกินแล้วเสียชีวิตแทบทุกปี</a:t>
             </a:r>
@@ -2494,9 +2389,8 @@
           <a:solidFill>
             <a:srgbClr val="EAF3EF"/>
           </a:solidFill>
-          <a:ln/>
           <a:effectLst>
-            <a:outerShdw sx="100000" sy="100000" kx="0" ky="0" algn="bl" rotWithShape="0" blurRad="76200" dist="25400" dir="5400000">
+            <a:outerShdw blurRad="76200" dist="25400" dir="5400000" algn="bl" rotWithShape="0">
               <a:srgbClr val="9AA6A2">
                 <a:alpha val="35000"/>
               </a:srgbClr>
@@ -2519,13 +2413,12 @@
             <a:avLst/>
           </a:prstGeom>
           <a:noFill/>
-          <a:ln/>
         </p:spPr>
         <p:txBody>
           <a:bodyPr wrap="square" lIns="0" tIns="0" rIns="0" bIns="0" rtlCol="0" anchor="ctr"/>
           <a:lstStyle/>
           <a:p>
-            <a:pPr algn="l" indent="0" marL="0">
+            <a:pPr marL="0" indent="0" algn="l">
               <a:spcAft>
                 <a:spcPts val="1000"/>
               </a:spcAft>
@@ -2536,16 +2429,16 @@
                 <a:solidFill>
                   <a:srgbClr val="0F6E56"/>
                 </a:solidFill>
-                <a:latin typeface="Tahoma" pitchFamily="34" charset="0"/>
-                <a:ea typeface="Tahoma" pitchFamily="34" charset="-122"/>
-                <a:cs typeface="Tahoma" pitchFamily="34" charset="-120"/>
+                <a:latin typeface="Tahoma" panose="020B0604030504040204" pitchFamily="34" charset="0"/>
+                <a:ea typeface="Tahoma" panose="020B0604030504040204" pitchFamily="34" charset="-122"/>
+                <a:cs typeface="Tahoma" panose="020B0604030504040204" pitchFamily="34" charset="-120"/>
               </a:rPr>
               <a:t>คำถามวิจัย</a:t>
             </a:r>
             <a:endParaRPr lang="en-US" sz="1600" dirty="0"/>
           </a:p>
           <a:p>
-            <a:pPr algn="l" indent="0" marL="0">
+            <a:pPr marL="0" indent="0" algn="l">
               <a:buNone/>
             </a:pPr>
             <a:r>
@@ -2553,9 +2446,9 @@
                 <a:solidFill>
                   <a:srgbClr val="22302E"/>
                 </a:solidFill>
-                <a:latin typeface="Tahoma" pitchFamily="34" charset="0"/>
-                <a:ea typeface="Tahoma" pitchFamily="34" charset="-122"/>
-                <a:cs typeface="Tahoma" pitchFamily="34" charset="-120"/>
+                <a:latin typeface="Tahoma" panose="020B0604030504040204" pitchFamily="34" charset="0"/>
+                <a:ea typeface="Tahoma" panose="020B0604030504040204" pitchFamily="34" charset="-122"/>
+                <a:cs typeface="Tahoma" panose="020B0604030504040204" pitchFamily="34" charset="-120"/>
               </a:rPr>
               <a:t>ถ้าไม่มีป้ายให้ AI จะเรียนรู้เองได้ไหม และ "ปลอดภัย" แค่ไหน เมื่ออันตรายเปลี่ยนไปตามเวลา?</a:t>
             </a:r>
@@ -2573,7 +2466,7 @@
 
 <file path=ppt/slides/slide3.xml><?xml version="1.0" encoding="utf-8"?>
 <p:sld xmlns:a="http://schemas.openxmlformats.org/drawingml/2006/main" xmlns:r="http://schemas.openxmlformats.org/officeDocument/2006/relationships" xmlns:p="http://schemas.openxmlformats.org/presentationml/2006/main">
-  <p:cSld name="Slide 3">
+  <p:cSld>
     <p:spTree>
       <p:nvGrpSpPr>
         <p:cNvPr id="1" name=""/>
@@ -2605,7 +2498,6 @@
           <a:solidFill>
             <a:srgbClr val="0F6E56"/>
           </a:solidFill>
-          <a:ln/>
         </p:spPr>
       </p:sp>
       <p:sp>
@@ -2623,13 +2515,12 @@
             <a:avLst/>
           </a:prstGeom>
           <a:noFill/>
-          <a:ln/>
         </p:spPr>
         <p:txBody>
           <a:bodyPr wrap="square" lIns="0" tIns="0" rIns="0" bIns="0" rtlCol="0" anchor="ctr"/>
           <a:lstStyle/>
           <a:p>
-            <a:pPr algn="ctr" indent="0" marL="0">
+            <a:pPr marL="0" indent="0" algn="ctr">
               <a:buNone/>
             </a:pPr>
             <a:r>
@@ -2637,9 +2528,9 @@
                 <a:solidFill>
                   <a:srgbClr val="FFFFFF"/>
                 </a:solidFill>
-                <a:latin typeface="Tahoma" pitchFamily="34" charset="0"/>
-                <a:ea typeface="Tahoma" pitchFamily="34" charset="-122"/>
-                <a:cs typeface="Tahoma" pitchFamily="34" charset="-120"/>
+                <a:latin typeface="Tahoma" panose="020B0604030504040204" pitchFamily="34" charset="0"/>
+                <a:ea typeface="Tahoma" panose="020B0604030504040204" pitchFamily="34" charset="-122"/>
+                <a:cs typeface="Tahoma" panose="020B0604030504040204" pitchFamily="34" charset="-120"/>
               </a:rPr>
               <a:t>2</a:t>
             </a:r>
@@ -2662,13 +2553,12 @@
             <a:avLst/>
           </a:prstGeom>
           <a:noFill/>
-          <a:ln/>
         </p:spPr>
         <p:txBody>
           <a:bodyPr wrap="square" lIns="0" tIns="0" rIns="0" bIns="0" rtlCol="0" anchor="ctr"/>
           <a:lstStyle/>
           <a:p>
-            <a:pPr algn="l" indent="0" marL="0">
+            <a:pPr marL="0" indent="0" algn="l">
               <a:buNone/>
             </a:pPr>
             <a:r>
@@ -2676,9 +2566,9 @@
                 <a:solidFill>
                   <a:srgbClr val="22302E"/>
                 </a:solidFill>
-                <a:latin typeface="Tahoma" pitchFamily="34" charset="0"/>
-                <a:ea typeface="Tahoma" pitchFamily="34" charset="-122"/>
-                <a:cs typeface="Tahoma" pitchFamily="34" charset="-120"/>
+                <a:latin typeface="Tahoma" panose="020B0604030504040204" pitchFamily="34" charset="0"/>
+                <a:ea typeface="Tahoma" panose="020B0604030504040204" pitchFamily="34" charset="-122"/>
+                <a:cs typeface="Tahoma" panose="020B0604030504040204" pitchFamily="34" charset="-120"/>
               </a:rPr>
               <a:t>สิ่งที่สร้าง: โลกจำลองที่ไม่มีป้ายกำกับ</a:t>
             </a:r>
@@ -2688,7 +2578,7 @@
       </p:sp>
       <p:pic>
         <p:nvPicPr>
-          <p:cNvPr id="5" name="Image 0" descr="C:\artificial-evolution\reports\figures\fig_world_overview.png">    </p:cNvPr>
+          <p:cNvPr id="5" name="Image 0" descr="C:\artificial-evolution\reports\figures\fig_world_overview.png"/>
           <p:cNvPicPr>
             <a:picLocks noChangeAspect="1"/>
           </p:cNvPicPr>
@@ -2696,8 +2586,10 @@
         </p:nvPicPr>
         <p:blipFill>
           <a:blip r:embed="rId1"/>
-          <a:srcRect l="0" r="0" t="0" b="0"/>
-          <a:stretch/>
+          <a:srcRect/>
+          <a:stretch>
+            <a:fillRect/>
+          </a:stretch>
         </p:blipFill>
         <p:spPr>
           <a:xfrm>
@@ -2708,7 +2600,7 @@
             <a:avLst/>
           </a:prstGeom>
           <a:effectLst>
-            <a:outerShdw sx="100000" sy="100000" kx="0" ky="0" algn="bl" rotWithShape="0" blurRad="76200" dist="25400" dir="5400000">
+            <a:outerShdw blurRad="76200" dist="25400" dir="5400000" algn="bl" rotWithShape="0">
               <a:srgbClr val="9AA6A2">
                 <a:alpha val="35000"/>
               </a:srgbClr>
@@ -2731,13 +2623,12 @@
             <a:avLst/>
           </a:prstGeom>
           <a:noFill/>
-          <a:ln/>
         </p:spPr>
         <p:txBody>
           <a:bodyPr wrap="square" lIns="0" tIns="0" rIns="0" bIns="0" rtlCol="0" anchor="t"/>
           <a:lstStyle/>
           <a:p>
-            <a:pPr algn="l" marL="177800" indent="-177800">
+            <a:pPr marL="177800" indent="-177800" algn="l">
               <a:spcAft>
                 <a:spcPts val="800"/>
               </a:spcAft>
@@ -2749,16 +2640,16 @@
                 <a:solidFill>
                   <a:srgbClr val="22302E"/>
                 </a:solidFill>
-                <a:latin typeface="Tahoma" pitchFamily="34" charset="0"/>
-                <a:ea typeface="Tahoma" pitchFamily="34" charset="-122"/>
-                <a:cs typeface="Tahoma" pitchFamily="34" charset="-120"/>
+                <a:latin typeface="Tahoma" panose="020B0604030504040204" pitchFamily="34" charset="0"/>
+                <a:ea typeface="Tahoma" panose="020B0604030504040204" pitchFamily="34" charset="-122"/>
+                <a:cs typeface="Tahoma" panose="020B0604030504040204" pitchFamily="34" charset="-120"/>
               </a:rPr>
               <a:t>โลกจำลองสิ่งมีชีวิต 2 มิติ ที่ AI ต้องหากินเพื่ออยู่รอด</a:t>
             </a:r>
             <a:endParaRPr lang="en-US" sz="1600" dirty="0"/>
           </a:p>
           <a:p>
-            <a:pPr algn="l" marL="177800" indent="-177800">
+            <a:pPr marL="177800" indent="-177800" algn="l">
               <a:spcAft>
                 <a:spcPts val="800"/>
               </a:spcAft>
@@ -2770,16 +2661,16 @@
                 <a:solidFill>
                   <a:srgbClr val="22302E"/>
                 </a:solidFill>
-                <a:latin typeface="Tahoma" pitchFamily="34" charset="0"/>
-                <a:ea typeface="Tahoma" pitchFamily="34" charset="-122"/>
-                <a:cs typeface="Tahoma" pitchFamily="34" charset="-120"/>
+                <a:latin typeface="Tahoma" panose="020B0604030504040204" pitchFamily="34" charset="0"/>
+                <a:ea typeface="Tahoma" panose="020B0604030504040204" pitchFamily="34" charset="-122"/>
+                <a:cs typeface="Tahoma" panose="020B0604030504040204" pitchFamily="34" charset="-120"/>
               </a:rPr>
               <a:t>กฎเหล็ก: ไม่มีป้ายบอกว่าอะไรมีค่า/มีพิษ</a:t>
             </a:r>
             <a:endParaRPr lang="en-US" sz="1600" dirty="0"/>
           </a:p>
           <a:p>
-            <a:pPr algn="l" marL="177800" indent="-177800">
+            <a:pPr marL="177800" indent="-177800" algn="l">
               <a:spcAft>
                 <a:spcPts val="800"/>
               </a:spcAft>
@@ -2791,16 +2682,16 @@
                 <a:solidFill>
                   <a:srgbClr val="22302E"/>
                 </a:solidFill>
-                <a:latin typeface="Tahoma" pitchFamily="34" charset="0"/>
-                <a:ea typeface="Tahoma" pitchFamily="34" charset="-122"/>
-                <a:cs typeface="Tahoma" pitchFamily="34" charset="-120"/>
+                <a:latin typeface="Tahoma" panose="020B0604030504040204" pitchFamily="34" charset="0"/>
+                <a:ea typeface="Tahoma" panose="020B0604030504040204" pitchFamily="34" charset="-122"/>
+                <a:cs typeface="Tahoma" panose="020B0604030504040204" pitchFamily="34" charset="-120"/>
               </a:rPr>
               <a:t>AI เรียนเองจาก "พลังงานสุทธิที่ได้รับจริง"</a:t>
             </a:r>
             <a:endParaRPr lang="en-US" sz="1600" dirty="0"/>
           </a:p>
           <a:p>
-            <a:pPr algn="l" marL="177800" indent="-177800">
+            <a:pPr marL="177800" indent="-177800" algn="l">
               <a:spcAft>
                 <a:spcPts val="800"/>
               </a:spcAft>
@@ -2812,9 +2703,9 @@
                 <a:solidFill>
                   <a:srgbClr val="22302E"/>
                 </a:solidFill>
-                <a:latin typeface="Tahoma" pitchFamily="34" charset="0"/>
-                <a:ea typeface="Tahoma" pitchFamily="34" charset="-122"/>
-                <a:cs typeface="Tahoma" pitchFamily="34" charset="-120"/>
+                <a:latin typeface="Tahoma" panose="020B0604030504040204" pitchFamily="34" charset="0"/>
+                <a:ea typeface="Tahoma" panose="020B0604030504040204" pitchFamily="34" charset="-122"/>
+                <a:cs typeface="Tahoma" panose="020B0604030504040204" pitchFamily="34" charset="-120"/>
               </a:rPr>
               <a:t>ผ่านการทดสอบอัตโนมัติ 93/93 และรันซ้ำได้ผลเดิม</a:t>
             </a:r>
@@ -2832,7 +2723,7 @@
 
 <file path=ppt/slides/slide4.xml><?xml version="1.0" encoding="utf-8"?>
 <p:sld xmlns:a="http://schemas.openxmlformats.org/drawingml/2006/main" xmlns:r="http://schemas.openxmlformats.org/officeDocument/2006/relationships" xmlns:p="http://schemas.openxmlformats.org/presentationml/2006/main">
-  <p:cSld name="Slide 4">
+  <p:cSld>
     <p:spTree>
       <p:nvGrpSpPr>
         <p:cNvPr id="1" name=""/>
@@ -2864,7 +2755,6 @@
           <a:solidFill>
             <a:srgbClr val="0F6E56"/>
           </a:solidFill>
-          <a:ln/>
         </p:spPr>
       </p:sp>
       <p:sp>
@@ -2882,13 +2772,12 @@
             <a:avLst/>
           </a:prstGeom>
           <a:noFill/>
-          <a:ln/>
         </p:spPr>
         <p:txBody>
           <a:bodyPr wrap="square" lIns="0" tIns="0" rIns="0" bIns="0" rtlCol="0" anchor="ctr"/>
           <a:lstStyle/>
           <a:p>
-            <a:pPr algn="ctr" indent="0" marL="0">
+            <a:pPr marL="0" indent="0" algn="ctr">
               <a:buNone/>
             </a:pPr>
             <a:r>
@@ -2896,9 +2785,9 @@
                 <a:solidFill>
                   <a:srgbClr val="FFFFFF"/>
                 </a:solidFill>
-                <a:latin typeface="Tahoma" pitchFamily="34" charset="0"/>
-                <a:ea typeface="Tahoma" pitchFamily="34" charset="-122"/>
-                <a:cs typeface="Tahoma" pitchFamily="34" charset="-120"/>
+                <a:latin typeface="Tahoma" panose="020B0604030504040204" pitchFamily="34" charset="0"/>
+                <a:ea typeface="Tahoma" panose="020B0604030504040204" pitchFamily="34" charset="-122"/>
+                <a:cs typeface="Tahoma" panose="020B0604030504040204" pitchFamily="34" charset="-120"/>
               </a:rPr>
               <a:t>3</a:t>
             </a:r>
@@ -2921,13 +2810,12 @@
             <a:avLst/>
           </a:prstGeom>
           <a:noFill/>
-          <a:ln/>
         </p:spPr>
         <p:txBody>
           <a:bodyPr wrap="square" lIns="0" tIns="0" rIns="0" bIns="0" rtlCol="0" anchor="ctr"/>
           <a:lstStyle/>
           <a:p>
-            <a:pPr algn="l" indent="0" marL="0">
+            <a:pPr marL="0" indent="0" algn="l">
               <a:buNone/>
             </a:pPr>
             <a:r>
@@ -2935,9 +2823,9 @@
                 <a:solidFill>
                   <a:srgbClr val="22302E"/>
                 </a:solidFill>
-                <a:latin typeface="Tahoma" pitchFamily="34" charset="0"/>
-                <a:ea typeface="Tahoma" pitchFamily="34" charset="-122"/>
-                <a:cs typeface="Tahoma" pitchFamily="34" charset="-120"/>
+                <a:latin typeface="Tahoma" panose="020B0604030504040204" pitchFamily="34" charset="0"/>
+                <a:ea typeface="Tahoma" panose="020B0604030504040204" pitchFamily="34" charset="-122"/>
+                <a:cs typeface="Tahoma" panose="020B0604030504040204" pitchFamily="34" charset="-120"/>
               </a:rPr>
               <a:t>องก์ 1 (รากฐาน): AI เรียนเลือกอาหารคุ้มค่าได้เอง</a:t>
             </a:r>
@@ -2947,7 +2835,7 @@
       </p:sp>
       <p:pic>
         <p:nvPicPr>
-          <p:cNvPr id="5" name="Image 0" descr="C:\artificial-evolution\reports\figures\fig_multiseed_seed_consumption_CI.png">    </p:cNvPr>
+          <p:cNvPr id="5" name="Image 0" descr="C:\artificial-evolution\reports\figures\fig_multiseed_seed_consumption_CI.png"/>
           <p:cNvPicPr>
             <a:picLocks noChangeAspect="1"/>
           </p:cNvPicPr>
@@ -2955,8 +2843,10 @@
         </p:nvPicPr>
         <p:blipFill>
           <a:blip r:embed="rId1"/>
-          <a:srcRect l="0" r="0" t="0" b="0"/>
-          <a:stretch/>
+          <a:srcRect/>
+          <a:stretch>
+            <a:fillRect/>
+          </a:stretch>
         </p:blipFill>
         <p:spPr>
           <a:xfrm>
@@ -2967,7 +2857,7 @@
             <a:avLst/>
           </a:prstGeom>
           <a:effectLst>
-            <a:outerShdw sx="100000" sy="100000" kx="0" ky="0" algn="bl" rotWithShape="0" blurRad="76200" dist="25400" dir="5400000">
+            <a:outerShdw blurRad="76200" dist="25400" dir="5400000" algn="bl" rotWithShape="0">
               <a:srgbClr val="9AA6A2">
                 <a:alpha val="35000"/>
               </a:srgbClr>
@@ -2994,9 +2884,8 @@
           <a:solidFill>
             <a:srgbClr val="EAF3EF"/>
           </a:solidFill>
-          <a:ln/>
           <a:effectLst>
-            <a:outerShdw sx="100000" sy="100000" kx="0" ky="0" algn="bl" rotWithShape="0" blurRad="76200" dist="25400" dir="5400000">
+            <a:outerShdw blurRad="76200" dist="25400" dir="5400000" algn="bl" rotWithShape="0">
               <a:srgbClr val="9AA6A2">
                 <a:alpha val="35000"/>
               </a:srgbClr>
@@ -3019,13 +2908,12 @@
             <a:avLst/>
           </a:prstGeom>
           <a:noFill/>
-          <a:ln/>
         </p:spPr>
         <p:txBody>
           <a:bodyPr wrap="square" lIns="0" tIns="0" rIns="0" bIns="0" rtlCol="0" anchor="ctr"/>
           <a:lstStyle/>
           <a:p>
-            <a:pPr algn="ctr" indent="0" marL="0">
+            <a:pPr marL="0" indent="0" algn="ctr">
               <a:buNone/>
             </a:pPr>
             <a:r>
@@ -3033,9 +2921,9 @@
                 <a:solidFill>
                   <a:srgbClr val="0F6E56"/>
                 </a:solidFill>
-                <a:latin typeface="Tahoma" pitchFamily="34" charset="0"/>
-                <a:ea typeface="Tahoma" pitchFamily="34" charset="-122"/>
-                <a:cs typeface="Tahoma" pitchFamily="34" charset="-120"/>
+                <a:latin typeface="Tahoma" panose="020B0604030504040204" pitchFamily="34" charset="0"/>
+                <a:ea typeface="Tahoma" panose="020B0604030504040204" pitchFamily="34" charset="-122"/>
+                <a:cs typeface="Tahoma" panose="020B0604030504040204" pitchFamily="34" charset="-120"/>
               </a:rPr>
               <a:t>4.6×</a:t>
             </a:r>
@@ -3058,13 +2946,12 @@
             <a:avLst/>
           </a:prstGeom>
           <a:noFill/>
-          <a:ln/>
         </p:spPr>
         <p:txBody>
           <a:bodyPr wrap="square" lIns="0" tIns="0" rIns="0" bIns="0" rtlCol="0" anchor="t"/>
           <a:lstStyle/>
           <a:p>
-            <a:pPr algn="ctr" indent="0" marL="0">
+            <a:pPr marL="0" indent="0" algn="ctr">
               <a:buNone/>
             </a:pPr>
             <a:r>
@@ -3072,9 +2959,9 @@
                 <a:solidFill>
                   <a:srgbClr val="22302E"/>
                 </a:solidFill>
-                <a:latin typeface="Tahoma" pitchFamily="34" charset="0"/>
-                <a:ea typeface="Tahoma" pitchFamily="34" charset="-122"/>
-                <a:cs typeface="Tahoma" pitchFamily="34" charset="-120"/>
+                <a:latin typeface="Tahoma" panose="020B0604030504040204" pitchFamily="34" charset="0"/>
+                <a:ea typeface="Tahoma" panose="020B0604030504040204" pitchFamily="34" charset="-122"/>
+                <a:cs typeface="Tahoma" panose="020B0604030504040204" pitchFamily="34" charset="-120"/>
               </a:rPr>
               <a:t>กินค่าต่ำน้อยลง</a:t>
             </a:r>
@@ -3101,9 +2988,8 @@
           <a:solidFill>
             <a:srgbClr val="EAF3EF"/>
           </a:solidFill>
-          <a:ln/>
           <a:effectLst>
-            <a:outerShdw sx="100000" sy="100000" kx="0" ky="0" algn="bl" rotWithShape="0" blurRad="76200" dist="25400" dir="5400000">
+            <a:outerShdw blurRad="76200" dist="25400" dir="5400000" algn="bl" rotWithShape="0">
               <a:srgbClr val="9AA6A2">
                 <a:alpha val="35000"/>
               </a:srgbClr>
@@ -3126,13 +3012,12 @@
             <a:avLst/>
           </a:prstGeom>
           <a:noFill/>
-          <a:ln/>
         </p:spPr>
         <p:txBody>
           <a:bodyPr wrap="square" lIns="0" tIns="0" rIns="0" bIns="0" rtlCol="0" anchor="ctr"/>
           <a:lstStyle/>
           <a:p>
-            <a:pPr algn="ctr" indent="0" marL="0">
+            <a:pPr marL="0" indent="0" algn="ctr">
               <a:buNone/>
             </a:pPr>
             <a:r>
@@ -3140,9 +3025,9 @@
                 <a:solidFill>
                   <a:srgbClr val="0F6E56"/>
                 </a:solidFill>
-                <a:latin typeface="Tahoma" pitchFamily="34" charset="0"/>
-                <a:ea typeface="Tahoma" pitchFamily="34" charset="-122"/>
-                <a:cs typeface="Tahoma" pitchFamily="34" charset="-120"/>
+                <a:latin typeface="Tahoma" panose="020B0604030504040204" pitchFamily="34" charset="0"/>
+                <a:ea typeface="Tahoma" panose="020B0604030504040204" pitchFamily="34" charset="-122"/>
+                <a:cs typeface="Tahoma" panose="020B0604030504040204" pitchFamily="34" charset="-120"/>
               </a:rPr>
               <a:t>p=.0002</a:t>
             </a:r>
@@ -3165,13 +3050,12 @@
             <a:avLst/>
           </a:prstGeom>
           <a:noFill/>
-          <a:ln/>
         </p:spPr>
         <p:txBody>
           <a:bodyPr wrap="square" lIns="0" tIns="0" rIns="0" bIns="0" rtlCol="0" anchor="t"/>
           <a:lstStyle/>
           <a:p>
-            <a:pPr algn="ctr" indent="0" marL="0">
+            <a:pPr marL="0" indent="0" algn="ctr">
               <a:buNone/>
             </a:pPr>
             <a:r>
@@ -3179,9 +3063,9 @@
                 <a:solidFill>
                   <a:srgbClr val="22302E"/>
                 </a:solidFill>
-                <a:latin typeface="Tahoma" pitchFamily="34" charset="0"/>
-                <a:ea typeface="Tahoma" pitchFamily="34" charset="-122"/>
-                <a:cs typeface="Tahoma" pitchFamily="34" charset="-120"/>
+                <a:latin typeface="Tahoma" panose="020B0604030504040204" pitchFamily="34" charset="0"/>
+                <a:ea typeface="Tahoma" panose="020B0604030504040204" pitchFamily="34" charset="-122"/>
+                <a:cs typeface="Tahoma" panose="020B0604030504040204" pitchFamily="34" charset="-120"/>
               </a:rPr>
               <a:t>10 ซีด · แยกขาด</a:t>
             </a:r>
@@ -3208,9 +3092,8 @@
           <a:solidFill>
             <a:srgbClr val="F7E9E7"/>
           </a:solidFill>
-          <a:ln/>
           <a:effectLst>
-            <a:outerShdw sx="100000" sy="100000" kx="0" ky="0" algn="bl" rotWithShape="0" blurRad="76200" dist="25400" dir="5400000">
+            <a:outerShdw blurRad="76200" dist="25400" dir="5400000" algn="bl" rotWithShape="0">
               <a:srgbClr val="9AA6A2">
                 <a:alpha val="35000"/>
               </a:srgbClr>
@@ -3233,13 +3116,12 @@
             <a:avLst/>
           </a:prstGeom>
           <a:noFill/>
-          <a:ln/>
         </p:spPr>
         <p:txBody>
           <a:bodyPr wrap="square" lIns="0" tIns="0" rIns="0" bIns="0" rtlCol="0" anchor="ctr"/>
           <a:lstStyle/>
           <a:p>
-            <a:pPr algn="ctr" indent="0" marL="0">
+            <a:pPr marL="0" indent="0" algn="ctr">
               <a:buNone/>
             </a:pPr>
             <a:r>
@@ -3247,9 +3129,9 @@
                 <a:solidFill>
                   <a:srgbClr val="B2352E"/>
                 </a:solidFill>
-                <a:latin typeface="Tahoma" pitchFamily="34" charset="0"/>
-                <a:ea typeface="Tahoma" pitchFamily="34" charset="-122"/>
-                <a:cs typeface="Tahoma" pitchFamily="34" charset="-120"/>
+                <a:latin typeface="Tahoma" panose="020B0604030504040204" pitchFamily="34" charset="0"/>
+                <a:ea typeface="Tahoma" panose="020B0604030504040204" pitchFamily="34" charset="-122"/>
+                <a:cs typeface="Tahoma" panose="020B0604030504040204" pitchFamily="34" charset="-120"/>
               </a:rPr>
               <a:t>0/12</a:t>
             </a:r>
@@ -3272,13 +3154,12 @@
             <a:avLst/>
           </a:prstGeom>
           <a:noFill/>
-          <a:ln/>
         </p:spPr>
         <p:txBody>
           <a:bodyPr wrap="square" lIns="0" tIns="0" rIns="0" bIns="0" rtlCol="0" anchor="t"/>
           <a:lstStyle/>
           <a:p>
-            <a:pPr algn="ctr" indent="0" marL="0">
+            <a:pPr marL="0" indent="0" algn="ctr">
               <a:buNone/>
             </a:pPr>
             <a:r>
@@ -3286,9 +3167,9 @@
                 <a:solidFill>
                   <a:srgbClr val="22302E"/>
                 </a:solidFill>
-                <a:latin typeface="Tahoma" pitchFamily="34" charset="0"/>
-                <a:ea typeface="Tahoma" pitchFamily="34" charset="-122"/>
-                <a:cs typeface="Tahoma" pitchFamily="34" charset="-120"/>
+                <a:latin typeface="Tahoma" panose="020B0604030504040204" pitchFamily="34" charset="0"/>
+                <a:ea typeface="Tahoma" panose="020B0604030504040204" pitchFamily="34" charset="-122"/>
+                <a:cs typeface="Tahoma" panose="020B0604030504040204" pitchFamily="34" charset="-120"/>
               </a:rPr>
               <a:t>เมินโดยไม่เคยชิม</a:t>
             </a:r>
@@ -3315,9 +3196,8 @@
           <a:solidFill>
             <a:srgbClr val="F6EEDD"/>
           </a:solidFill>
-          <a:ln/>
           <a:effectLst>
-            <a:outerShdw sx="100000" sy="100000" kx="0" ky="0" algn="bl" rotWithShape="0" blurRad="76200" dist="25400" dir="5400000">
+            <a:outerShdw blurRad="76200" dist="25400" dir="5400000" algn="bl" rotWithShape="0">
               <a:srgbClr val="9AA6A2">
                 <a:alpha val="35000"/>
               </a:srgbClr>
@@ -3340,13 +3220,12 @@
             <a:avLst/>
           </a:prstGeom>
           <a:noFill/>
-          <a:ln/>
         </p:spPr>
         <p:txBody>
           <a:bodyPr wrap="square" lIns="0" tIns="0" rIns="0" bIns="0" rtlCol="0" anchor="ctr"/>
           <a:lstStyle/>
           <a:p>
-            <a:pPr algn="l" indent="0" marL="0">
+            <a:pPr marL="0" indent="0" algn="l">
               <a:buNone/>
             </a:pPr>
             <a:r>
@@ -3354,23 +3233,20 @@
                 <a:solidFill>
                   <a:srgbClr val="B7791F"/>
                 </a:solidFill>
-                <a:latin typeface="Tahoma" pitchFamily="34" charset="0"/>
-                <a:ea typeface="Tahoma" pitchFamily="34" charset="-122"/>
-                <a:cs typeface="Tahoma" pitchFamily="34" charset="-120"/>
+                <a:latin typeface="Tahoma" panose="020B0604030504040204" pitchFamily="34" charset="0"/>
+                <a:ea typeface="Tahoma" panose="020B0604030504040204" pitchFamily="34" charset="-122"/>
+                <a:cs typeface="Tahoma" panose="020B0604030504040204" pitchFamily="34" charset="-120"/>
               </a:rPr>
               <a:t>หลักฐานเชิงสาเหตุ: </a:t>
             </a:r>
-            <a:pPr algn="l" indent="0" marL="0">
-              <a:buNone/>
-            </a:pPr>
             <a:r>
               <a:rPr lang="en-US" sz="1450" dirty="0">
                 <a:solidFill>
                   <a:srgbClr val="22302E"/>
                 </a:solidFill>
-                <a:latin typeface="Tahoma" pitchFamily="34" charset="0"/>
-                <a:ea typeface="Tahoma" pitchFamily="34" charset="-122"/>
-                <a:cs typeface="Tahoma" pitchFamily="34" charset="-120"/>
+                <a:latin typeface="Tahoma" panose="020B0604030504040204" pitchFamily="34" charset="0"/>
+                <a:ea typeface="Tahoma" panose="020B0604030504040204" pitchFamily="34" charset="-122"/>
+                <a:cs typeface="Tahoma" panose="020B0604030504040204" pitchFamily="34" charset="-120"/>
               </a:rPr>
               <a:t>ไม่มีเอเจนต์สักตัวที่เมินอาหารค่าต่ำโดยไม่เคยชิมอาหารที่ดีกว่าก่อน → พฤติกรรมมาจากประสบการณ์ตรง ไม่ใช่กฎที่เขียนใส่</a:t>
             </a:r>
@@ -3388,7 +3264,7 @@
 
 <file path=ppt/slides/slide5.xml><?xml version="1.0" encoding="utf-8"?>
 <p:sld xmlns:a="http://schemas.openxmlformats.org/drawingml/2006/main" xmlns:r="http://schemas.openxmlformats.org/officeDocument/2006/relationships" xmlns:p="http://schemas.openxmlformats.org/presentationml/2006/main">
-  <p:cSld name="Slide 5">
+  <p:cSld>
     <p:spTree>
       <p:nvGrpSpPr>
         <p:cNvPr id="1" name=""/>
@@ -3420,7 +3296,6 @@
           <a:solidFill>
             <a:srgbClr val="0F6E56"/>
           </a:solidFill>
-          <a:ln/>
         </p:spPr>
       </p:sp>
       <p:sp>
@@ -3438,13 +3313,12 @@
             <a:avLst/>
           </a:prstGeom>
           <a:noFill/>
-          <a:ln/>
         </p:spPr>
         <p:txBody>
           <a:bodyPr wrap="square" lIns="0" tIns="0" rIns="0" bIns="0" rtlCol="0" anchor="ctr"/>
           <a:lstStyle/>
           <a:p>
-            <a:pPr algn="ctr" indent="0" marL="0">
+            <a:pPr marL="0" indent="0" algn="ctr">
               <a:buNone/>
             </a:pPr>
             <a:r>
@@ -3452,9 +3326,9 @@
                 <a:solidFill>
                   <a:srgbClr val="FFFFFF"/>
                 </a:solidFill>
-                <a:latin typeface="Tahoma" pitchFamily="34" charset="0"/>
-                <a:ea typeface="Tahoma" pitchFamily="34" charset="-122"/>
-                <a:cs typeface="Tahoma" pitchFamily="34" charset="-120"/>
+                <a:latin typeface="Tahoma" panose="020B0604030504040204" pitchFamily="34" charset="0"/>
+                <a:ea typeface="Tahoma" panose="020B0604030504040204" pitchFamily="34" charset="-122"/>
+                <a:cs typeface="Tahoma" panose="020B0604030504040204" pitchFamily="34" charset="-120"/>
               </a:rPr>
               <a:t>4</a:t>
             </a:r>
@@ -3477,13 +3351,12 @@
             <a:avLst/>
           </a:prstGeom>
           <a:noFill/>
-          <a:ln/>
         </p:spPr>
         <p:txBody>
           <a:bodyPr wrap="square" lIns="0" tIns="0" rIns="0" bIns="0" rtlCol="0" anchor="ctr"/>
           <a:lstStyle/>
           <a:p>
-            <a:pPr algn="l" indent="0" marL="0">
+            <a:pPr marL="0" indent="0" algn="l">
               <a:buNone/>
             </a:pPr>
             <a:r>
@@ -3491,9 +3364,9 @@
                 <a:solidFill>
                   <a:srgbClr val="22302E"/>
                 </a:solidFill>
-                <a:latin typeface="Tahoma" pitchFamily="34" charset="0"/>
-                <a:ea typeface="Tahoma" pitchFamily="34" charset="-122"/>
-                <a:cs typeface="Tahoma" pitchFamily="34" charset="-120"/>
+                <a:latin typeface="Tahoma" panose="020B0604030504040204" pitchFamily="34" charset="0"/>
+                <a:ea typeface="Tahoma" panose="020B0604030504040204" pitchFamily="34" charset="-122"/>
+                <a:cs typeface="Tahoma" panose="020B0604030504040204" pitchFamily="34" charset="-120"/>
               </a:rPr>
               <a:t>องก์ 1 (ต่อ): เลี่ยง "พิษคงที่" ได้เอง</a:t>
             </a:r>
@@ -3503,7 +3376,7 @@
       </p:sp>
       <p:pic>
         <p:nvPicPr>
-          <p:cNvPr id="5" name="Image 0" descr="C:\artificial-evolution\reports\figures\toxin_fig3_learning_curve.png">    </p:cNvPr>
+          <p:cNvPr id="5" name="Image 0" descr="C:\artificial-evolution\reports\figures\toxin_fig3_learning_curve.png"/>
           <p:cNvPicPr>
             <a:picLocks noChangeAspect="1"/>
           </p:cNvPicPr>
@@ -3511,8 +3384,10 @@
         </p:nvPicPr>
         <p:blipFill>
           <a:blip r:embed="rId1"/>
-          <a:srcRect l="0" r="0" t="0" b="0"/>
-          <a:stretch/>
+          <a:srcRect/>
+          <a:stretch>
+            <a:fillRect/>
+          </a:stretch>
         </p:blipFill>
         <p:spPr>
           <a:xfrm>
@@ -3523,7 +3398,7 @@
             <a:avLst/>
           </a:prstGeom>
           <a:effectLst>
-            <a:outerShdw sx="100000" sy="100000" kx="0" ky="0" algn="bl" rotWithShape="0" blurRad="76200" dist="25400" dir="5400000">
+            <a:outerShdw blurRad="76200" dist="25400" dir="5400000" algn="bl" rotWithShape="0">
               <a:srgbClr val="9AA6A2">
                 <a:alpha val="35000"/>
               </a:srgbClr>
@@ -3546,13 +3421,12 @@
             <a:avLst/>
           </a:prstGeom>
           <a:noFill/>
-          <a:ln/>
         </p:spPr>
         <p:txBody>
           <a:bodyPr wrap="square" lIns="0" tIns="0" rIns="0" bIns="0" rtlCol="0" anchor="t"/>
           <a:lstStyle/>
           <a:p>
-            <a:pPr algn="l" marL="177800" indent="-177800">
+            <a:pPr marL="177800" indent="-177800" algn="l">
               <a:spcAft>
                 <a:spcPts val="800"/>
               </a:spcAft>
@@ -3564,16 +3438,16 @@
                 <a:solidFill>
                   <a:srgbClr val="22302E"/>
                 </a:solidFill>
-                <a:latin typeface="Tahoma" pitchFamily="34" charset="0"/>
-                <a:ea typeface="Tahoma" pitchFamily="34" charset="-122"/>
-                <a:cs typeface="Tahoma" pitchFamily="34" charset="-120"/>
+                <a:latin typeface="Tahoma" panose="020B0604030504040204" pitchFamily="34" charset="0"/>
+                <a:ea typeface="Tahoma" panose="020B0604030504040204" pitchFamily="34" charset="-122"/>
+                <a:cs typeface="Tahoma" panose="020B0604030504040204" pitchFamily="34" charset="-120"/>
               </a:rPr>
               <a:t>ใส่อาหารที่มีพิษคงที่</a:t>
             </a:r>
             <a:endParaRPr lang="en-US" sz="1600" dirty="0"/>
           </a:p>
           <a:p>
-            <a:pPr algn="l" marL="177800" indent="-177800">
+            <a:pPr marL="177800" indent="-177800" algn="l">
               <a:spcAft>
                 <a:spcPts val="800"/>
               </a:spcAft>
@@ -3585,16 +3459,16 @@
                 <a:solidFill>
                   <a:srgbClr val="22302E"/>
                 </a:solidFill>
-                <a:latin typeface="Tahoma" pitchFamily="34" charset="0"/>
-                <a:ea typeface="Tahoma" pitchFamily="34" charset="-122"/>
-                <a:cs typeface="Tahoma" pitchFamily="34" charset="-120"/>
+                <a:latin typeface="Tahoma" panose="020B0604030504040204" pitchFamily="34" charset="0"/>
+                <a:ea typeface="Tahoma" panose="020B0604030504040204" pitchFamily="34" charset="-122"/>
+                <a:cs typeface="Tahoma" panose="020B0604030504040204" pitchFamily="34" charset="-120"/>
               </a:rPr>
               <a:t>AI เริ่มจากลองชิม พอรู้ว่าไม่คุ้ม → เลี่ยงเองตลอด</a:t>
             </a:r>
             <a:endParaRPr lang="en-US" sz="1600" dirty="0"/>
           </a:p>
           <a:p>
-            <a:pPr algn="l" marL="177800" indent="-177800">
+            <a:pPr marL="177800" indent="-177800" algn="l">
               <a:spcAft>
                 <a:spcPts val="800"/>
               </a:spcAft>
@@ -3606,16 +3480,16 @@
                 <a:solidFill>
                   <a:srgbClr val="22302E"/>
                 </a:solidFill>
-                <a:latin typeface="Tahoma" pitchFamily="34" charset="0"/>
-                <a:ea typeface="Tahoma" pitchFamily="34" charset="-122"/>
-                <a:cs typeface="Tahoma" pitchFamily="34" charset="-120"/>
+                <a:latin typeface="Tahoma" panose="020B0604030504040204" pitchFamily="34" charset="0"/>
+                <a:ea typeface="Tahoma" panose="020B0604030504040204" pitchFamily="34" charset="-122"/>
+                <a:cs typeface="Tahoma" panose="020B0604030504040204" pitchFamily="34" charset="-120"/>
               </a:rPr>
               <a:t>ความน่าจะเป็นที่เลือกกิน ~100% → ใกล้ 0% ในไม่กี่รอบ</a:t>
             </a:r>
             <a:endParaRPr lang="en-US" sz="1600" dirty="0"/>
           </a:p>
           <a:p>
-            <a:pPr algn="l" marL="177800" indent="-177800">
+            <a:pPr marL="177800" indent="-177800" algn="l">
               <a:spcAft>
                 <a:spcPts val="800"/>
               </a:spcAft>
@@ -3627,9 +3501,9 @@
                 <a:solidFill>
                   <a:srgbClr val="22302E"/>
                 </a:solidFill>
-                <a:latin typeface="Tahoma" pitchFamily="34" charset="0"/>
-                <a:ea typeface="Tahoma" pitchFamily="34" charset="-122"/>
-                <a:cs typeface="Tahoma" pitchFamily="34" charset="-120"/>
+                <a:latin typeface="Tahoma" panose="020B0604030504040204" pitchFamily="34" charset="0"/>
+                <a:ea typeface="Tahoma" panose="020B0604030504040204" pitchFamily="34" charset="-122"/>
+                <a:cs typeface="Tahoma" panose="020B0604030504040204" pitchFamily="34" charset="-120"/>
               </a:rPr>
               <a:t>ไม่ได้เขียนกฎให้เลี่ยง — เรียนจากผลจริงล้วน ๆ</a:t>
             </a:r>
@@ -3647,7 +3521,7 @@
 
 <file path=ppt/slides/slide6.xml><?xml version="1.0" encoding="utf-8"?>
 <p:sld xmlns:a="http://schemas.openxmlformats.org/drawingml/2006/main" xmlns:r="http://schemas.openxmlformats.org/officeDocument/2006/relationships" xmlns:p="http://schemas.openxmlformats.org/presentationml/2006/main">
-  <p:cSld name="Slide 6">
+  <p:cSld>
     <p:spTree>
       <p:nvGrpSpPr>
         <p:cNvPr id="1" name=""/>
@@ -3679,7 +3553,6 @@
           <a:solidFill>
             <a:srgbClr val="0F6E56"/>
           </a:solidFill>
-          <a:ln/>
         </p:spPr>
       </p:sp>
       <p:sp>
@@ -3697,13 +3570,12 @@
             <a:avLst/>
           </a:prstGeom>
           <a:noFill/>
-          <a:ln/>
         </p:spPr>
         <p:txBody>
           <a:bodyPr wrap="square" lIns="0" tIns="0" rIns="0" bIns="0" rtlCol="0" anchor="ctr"/>
           <a:lstStyle/>
           <a:p>
-            <a:pPr algn="ctr" indent="0" marL="0">
+            <a:pPr marL="0" indent="0" algn="ctr">
               <a:buNone/>
             </a:pPr>
             <a:r>
@@ -3711,9 +3583,9 @@
                 <a:solidFill>
                   <a:srgbClr val="FFFFFF"/>
                 </a:solidFill>
-                <a:latin typeface="Tahoma" pitchFamily="34" charset="0"/>
-                <a:ea typeface="Tahoma" pitchFamily="34" charset="-122"/>
-                <a:cs typeface="Tahoma" pitchFamily="34" charset="-120"/>
+                <a:latin typeface="Tahoma" panose="020B0604030504040204" pitchFamily="34" charset="0"/>
+                <a:ea typeface="Tahoma" panose="020B0604030504040204" pitchFamily="34" charset="-122"/>
+                <a:cs typeface="Tahoma" panose="020B0604030504040204" pitchFamily="34" charset="-120"/>
               </a:rPr>
               <a:t>5</a:t>
             </a:r>
@@ -3736,13 +3608,12 @@
             <a:avLst/>
           </a:prstGeom>
           <a:noFill/>
-          <a:ln/>
         </p:spPr>
         <p:txBody>
           <a:bodyPr wrap="square" lIns="0" tIns="0" rIns="0" bIns="0" rtlCol="0" anchor="ctr"/>
           <a:lstStyle/>
           <a:p>
-            <a:pPr algn="l" indent="0" marL="0">
+            <a:pPr marL="0" indent="0" algn="l">
               <a:buNone/>
             </a:pPr>
             <a:r>
@@ -3750,9 +3621,9 @@
                 <a:solidFill>
                   <a:srgbClr val="22302E"/>
                 </a:solidFill>
-                <a:latin typeface="Tahoma" pitchFamily="34" charset="0"/>
-                <a:ea typeface="Tahoma" pitchFamily="34" charset="-122"/>
-                <a:cs typeface="Tahoma" pitchFamily="34" charset="-120"/>
+                <a:latin typeface="Tahoma" panose="020B0604030504040204" pitchFamily="34" charset="0"/>
+                <a:ea typeface="Tahoma" panose="020B0604030504040204" pitchFamily="34" charset="-122"/>
+                <a:cs typeface="Tahoma" panose="020B0604030504040204" pitchFamily="34" charset="-120"/>
               </a:rPr>
               <a:t>องก์ 2 (หมัดเด็ด): "พิษที่หายได้" หลอกให้กินพิษมากขึ้น</a:t>
             </a:r>
@@ -3762,7 +3633,7 @@
       </p:sp>
       <p:pic>
         <p:nvPicPr>
-          <p:cNvPr id="5" name="Image 0" descr="C:\artificial-evolution\reports\figures\toxin_multiseed_ci.png">    </p:cNvPr>
+          <p:cNvPr id="5" name="Image 0" descr="C:\artificial-evolution\reports\figures\toxin_multiseed_ci.png"/>
           <p:cNvPicPr>
             <a:picLocks noChangeAspect="1"/>
           </p:cNvPicPr>
@@ -3770,8 +3641,10 @@
         </p:nvPicPr>
         <p:blipFill>
           <a:blip r:embed="rId1"/>
-          <a:srcRect l="0" r="0" t="0" b="0"/>
-          <a:stretch/>
+          <a:srcRect/>
+          <a:stretch>
+            <a:fillRect/>
+          </a:stretch>
         </p:blipFill>
         <p:spPr>
           <a:xfrm>
@@ -3782,7 +3655,7 @@
             <a:avLst/>
           </a:prstGeom>
           <a:effectLst>
-            <a:outerShdw sx="100000" sy="100000" kx="0" ky="0" algn="bl" rotWithShape="0" blurRad="76200" dist="25400" dir="5400000">
+            <a:outerShdw blurRad="76200" dist="25400" dir="5400000" algn="bl" rotWithShape="0">
               <a:srgbClr val="9AA6A2">
                 <a:alpha val="35000"/>
               </a:srgbClr>
@@ -3809,9 +3682,8 @@
           <a:solidFill>
             <a:srgbClr val="F7E9E7"/>
           </a:solidFill>
-          <a:ln/>
           <a:effectLst>
-            <a:outerShdw sx="100000" sy="100000" kx="0" ky="0" algn="bl" rotWithShape="0" blurRad="76200" dist="25400" dir="5400000">
+            <a:outerShdw blurRad="76200" dist="25400" dir="5400000" algn="bl" rotWithShape="0">
               <a:srgbClr val="9AA6A2">
                 <a:alpha val="35000"/>
               </a:srgbClr>
@@ -3834,13 +3706,12 @@
             <a:avLst/>
           </a:prstGeom>
           <a:noFill/>
-          <a:ln/>
         </p:spPr>
         <p:txBody>
           <a:bodyPr wrap="square" lIns="0" tIns="0" rIns="0" bIns="0" rtlCol="0" anchor="ctr"/>
           <a:lstStyle/>
           <a:p>
-            <a:pPr algn="ctr" indent="0" marL="0">
+            <a:pPr marL="0" indent="0" algn="ctr">
               <a:buNone/>
             </a:pPr>
             <a:r>
@@ -3848,9 +3719,9 @@
                 <a:solidFill>
                   <a:srgbClr val="B2352E"/>
                 </a:solidFill>
-                <a:latin typeface="Tahoma" pitchFamily="34" charset="0"/>
-                <a:ea typeface="Tahoma" pitchFamily="34" charset="-122"/>
-                <a:cs typeface="Tahoma" pitchFamily="34" charset="-120"/>
+                <a:latin typeface="Tahoma" panose="020B0604030504040204" pitchFamily="34" charset="0"/>
+                <a:ea typeface="Tahoma" panose="020B0604030504040204" pitchFamily="34" charset="-122"/>
+                <a:cs typeface="Tahoma" panose="020B0604030504040204" pitchFamily="34" charset="-120"/>
               </a:rPr>
               <a:t>63%</a:t>
             </a:r>
@@ -3873,13 +3744,12 @@
             <a:avLst/>
           </a:prstGeom>
           <a:noFill/>
-          <a:ln/>
         </p:spPr>
         <p:txBody>
           <a:bodyPr wrap="square" lIns="0" tIns="0" rIns="0" bIns="0" rtlCol="0" anchor="t"/>
           <a:lstStyle/>
           <a:p>
-            <a:pPr algn="ctr" indent="0" marL="0">
+            <a:pPr marL="0" indent="0" algn="ctr">
               <a:buNone/>
             </a:pPr>
             <a:r>
@@ -3887,9 +3757,9 @@
                 <a:solidFill>
                   <a:srgbClr val="22302E"/>
                 </a:solidFill>
-                <a:latin typeface="Tahoma" pitchFamily="34" charset="0"/>
-                <a:ea typeface="Tahoma" pitchFamily="34" charset="-122"/>
-                <a:cs typeface="Tahoma" pitchFamily="34" charset="-120"/>
+                <a:latin typeface="Tahoma" panose="020B0604030504040204" pitchFamily="34" charset="0"/>
+                <a:ea typeface="Tahoma" panose="020B0604030504040204" pitchFamily="34" charset="-122"/>
+                <a:cs typeface="Tahoma" panose="020B0604030504040204" pitchFamily="34" charset="-120"/>
               </a:rPr>
               <a:t>ถูกหลอกที่พิษ 30%</a:t>
             </a:r>
@@ -3916,9 +3786,8 @@
           <a:solidFill>
             <a:srgbClr val="F7E9E7"/>
           </a:solidFill>
-          <a:ln/>
           <a:effectLst>
-            <a:outerShdw sx="100000" sy="100000" kx="0" ky="0" algn="bl" rotWithShape="0" blurRad="76200" dist="25400" dir="5400000">
+            <a:outerShdw blurRad="76200" dist="25400" dir="5400000" algn="bl" rotWithShape="0">
               <a:srgbClr val="9AA6A2">
                 <a:alpha val="35000"/>
               </a:srgbClr>
@@ -3941,13 +3810,12 @@
             <a:avLst/>
           </a:prstGeom>
           <a:noFill/>
-          <a:ln/>
         </p:spPr>
         <p:txBody>
           <a:bodyPr wrap="square" lIns="0" tIns="0" rIns="0" bIns="0" rtlCol="0" anchor="ctr"/>
           <a:lstStyle/>
           <a:p>
-            <a:pPr algn="ctr" indent="0" marL="0">
+            <a:pPr marL="0" indent="0" algn="ctr">
               <a:buNone/>
             </a:pPr>
             <a:r>
@@ -3955,9 +3823,9 @@
                 <a:solidFill>
                   <a:srgbClr val="B2352E"/>
                 </a:solidFill>
-                <a:latin typeface="Tahoma" pitchFamily="34" charset="0"/>
-                <a:ea typeface="Tahoma" pitchFamily="34" charset="-122"/>
-                <a:cs typeface="Tahoma" pitchFamily="34" charset="-120"/>
+                <a:latin typeface="Tahoma" panose="020B0604030504040204" pitchFamily="34" charset="0"/>
+                <a:ea typeface="Tahoma" panose="020B0604030504040204" pitchFamily="34" charset="-122"/>
+                <a:cs typeface="Tahoma" panose="020B0604030504040204" pitchFamily="34" charset="-120"/>
               </a:rPr>
               <a:t>99%</a:t>
             </a:r>
@@ -3980,13 +3848,12 @@
             <a:avLst/>
           </a:prstGeom>
           <a:noFill/>
-          <a:ln/>
         </p:spPr>
         <p:txBody>
           <a:bodyPr wrap="square" lIns="0" tIns="0" rIns="0" bIns="0" rtlCol="0" anchor="t"/>
           <a:lstStyle/>
           <a:p>
-            <a:pPr algn="ctr" indent="0" marL="0">
+            <a:pPr marL="0" indent="0" algn="ctr">
               <a:buNone/>
             </a:pPr>
             <a:r>
@@ -3994,9 +3861,9 @@
                 <a:solidFill>
                   <a:srgbClr val="22302E"/>
                 </a:solidFill>
-                <a:latin typeface="Tahoma" pitchFamily="34" charset="0"/>
-                <a:ea typeface="Tahoma" pitchFamily="34" charset="-122"/>
-                <a:cs typeface="Tahoma" pitchFamily="34" charset="-120"/>
+                <a:latin typeface="Tahoma" panose="020B0604030504040204" pitchFamily="34" charset="0"/>
+                <a:ea typeface="Tahoma" panose="020B0604030504040204" pitchFamily="34" charset="-122"/>
+                <a:cs typeface="Tahoma" panose="020B0604030504040204" pitchFamily="34" charset="-120"/>
               </a:rPr>
               <a:t>กับกฎ softmax</a:t>
             </a:r>
@@ -4023,9 +3890,8 @@
           <a:solidFill>
             <a:srgbClr val="F7E9E7"/>
           </a:solidFill>
-          <a:ln/>
           <a:effectLst>
-            <a:outerShdw sx="100000" sy="100000" kx="0" ky="0" algn="bl" rotWithShape="0" blurRad="76200" dist="25400" dir="5400000">
+            <a:outerShdw blurRad="76200" dist="25400" dir="5400000" algn="bl" rotWithShape="0">
               <a:srgbClr val="9AA6A2">
                 <a:alpha val="35000"/>
               </a:srgbClr>
@@ -4048,13 +3914,12 @@
             <a:avLst/>
           </a:prstGeom>
           <a:noFill/>
-          <a:ln/>
         </p:spPr>
         <p:txBody>
           <a:bodyPr wrap="square" lIns="0" tIns="0" rIns="0" bIns="0" rtlCol="0" anchor="ctr"/>
           <a:lstStyle/>
           <a:p>
-            <a:pPr algn="l" indent="0" marL="0">
+            <a:pPr marL="0" indent="0" algn="l">
               <a:buNone/>
             </a:pPr>
             <a:r>
@@ -4062,37 +3927,31 @@
                 <a:solidFill>
                   <a:srgbClr val="22302E"/>
                 </a:solidFill>
-                <a:latin typeface="Tahoma" pitchFamily="34" charset="0"/>
-                <a:ea typeface="Tahoma" pitchFamily="34" charset="-122"/>
-                <a:cs typeface="Tahoma" pitchFamily="34" charset="-120"/>
+                <a:latin typeface="Tahoma" panose="020B0604030504040204" pitchFamily="34" charset="0"/>
+                <a:ea typeface="Tahoma" panose="020B0604030504040204" pitchFamily="34" charset="-122"/>
+                <a:cs typeface="Tahoma" panose="020B0604030504040204" pitchFamily="34" charset="-120"/>
               </a:rPr>
               <a:t>อาหารสด = พิษ / เก็บไว้ = ปลอดภัย  →  AI มองไม่เห็น "อายุ" เรียนได้แค่ค่าเฉลี่ยที่สูงกว่าอาหารปลอดภัย  →  </a:t>
             </a:r>
-            <a:pPr algn="l" indent="0" marL="0">
-              <a:buNone/>
-            </a:pPr>
             <a:r>
               <a:rPr lang="en-US" sz="1700" b="1" dirty="0">
                 <a:solidFill>
                   <a:srgbClr val="B2352E"/>
                 </a:solidFill>
-                <a:latin typeface="Tahoma" pitchFamily="34" charset="0"/>
-                <a:ea typeface="Tahoma" pitchFamily="34" charset="-122"/>
-                <a:cs typeface="Tahoma" pitchFamily="34" charset="-120"/>
+                <a:latin typeface="Tahoma" panose="020B0604030504040204" pitchFamily="34" charset="0"/>
+                <a:ea typeface="Tahoma" panose="020B0604030504040204" pitchFamily="34" charset="-122"/>
+                <a:cs typeface="Tahoma" panose="020B0604030504040204" pitchFamily="34" charset="-120"/>
               </a:rPr>
               <a:t>พลิกจากการ "เลี่ยง" เป็นการ "ไล่ล่า"</a:t>
             </a:r>
-            <a:pPr algn="l" indent="0" marL="0">
-              <a:buNone/>
-            </a:pPr>
             <a:r>
               <a:rPr lang="en-US" sz="1700" dirty="0">
                 <a:solidFill>
                   <a:srgbClr val="22302E"/>
                 </a:solidFill>
-                <a:latin typeface="Tahoma" pitchFamily="34" charset="0"/>
-                <a:ea typeface="Tahoma" pitchFamily="34" charset="-122"/>
-                <a:cs typeface="Tahoma" pitchFamily="34" charset="-120"/>
+                <a:latin typeface="Tahoma" panose="020B0604030504040204" pitchFamily="34" charset="0"/>
+                <a:ea typeface="Tahoma" panose="020B0604030504040204" pitchFamily="34" charset="-122"/>
+                <a:cs typeface="Tahoma" panose="020B0604030504040204" pitchFamily="34" charset="-120"/>
               </a:rPr>
               <a:t> (กินพิษจริงราว 30% ของมื้อ)</a:t>
             </a:r>
@@ -4110,7 +3969,7 @@
 
 <file path=ppt/slides/slide7.xml><?xml version="1.0" encoding="utf-8"?>
 <p:sld xmlns:a="http://schemas.openxmlformats.org/drawingml/2006/main" xmlns:r="http://schemas.openxmlformats.org/officeDocument/2006/relationships" xmlns:p="http://schemas.openxmlformats.org/presentationml/2006/main">
-  <p:cSld name="Slide 7">
+  <p:cSld>
     <p:spTree>
       <p:nvGrpSpPr>
         <p:cNvPr id="1" name=""/>
@@ -4142,7 +4001,6 @@
           <a:solidFill>
             <a:srgbClr val="0F6E56"/>
           </a:solidFill>
-          <a:ln/>
         </p:spPr>
       </p:sp>
       <p:sp>
@@ -4160,13 +4018,12 @@
             <a:avLst/>
           </a:prstGeom>
           <a:noFill/>
-          <a:ln/>
         </p:spPr>
         <p:txBody>
           <a:bodyPr wrap="square" lIns="0" tIns="0" rIns="0" bIns="0" rtlCol="0" anchor="ctr"/>
           <a:lstStyle/>
           <a:p>
-            <a:pPr algn="ctr" indent="0" marL="0">
+            <a:pPr marL="0" indent="0" algn="ctr">
               <a:buNone/>
             </a:pPr>
             <a:r>
@@ -4174,9 +4031,9 @@
                 <a:solidFill>
                   <a:srgbClr val="FFFFFF"/>
                 </a:solidFill>
-                <a:latin typeface="Tahoma" pitchFamily="34" charset="0"/>
-                <a:ea typeface="Tahoma" pitchFamily="34" charset="-122"/>
-                <a:cs typeface="Tahoma" pitchFamily="34" charset="-120"/>
+                <a:latin typeface="Tahoma" panose="020B0604030504040204" pitchFamily="34" charset="0"/>
+                <a:ea typeface="Tahoma" panose="020B0604030504040204" pitchFamily="34" charset="-122"/>
+                <a:cs typeface="Tahoma" panose="020B0604030504040204" pitchFamily="34" charset="-120"/>
               </a:rPr>
               <a:t>6</a:t>
             </a:r>
@@ -4199,13 +4056,12 @@
             <a:avLst/>
           </a:prstGeom>
           <a:noFill/>
-          <a:ln/>
         </p:spPr>
         <p:txBody>
           <a:bodyPr wrap="square" lIns="0" tIns="0" rIns="0" bIns="0" rtlCol="0" anchor="ctr"/>
           <a:lstStyle/>
           <a:p>
-            <a:pPr algn="l" indent="0" marL="0">
+            <a:pPr marL="0" indent="0" algn="l">
               <a:buNone/>
             </a:pPr>
             <a:r>
@@ -4213,9 +4069,9 @@
                 <a:solidFill>
                   <a:srgbClr val="22302E"/>
                 </a:solidFill>
-                <a:latin typeface="Tahoma" pitchFamily="34" charset="0"/>
-                <a:ea typeface="Tahoma" pitchFamily="34" charset="-122"/>
-                <a:cs typeface="Tahoma" pitchFamily="34" charset="-120"/>
+                <a:latin typeface="Tahoma" panose="020B0604030504040204" pitchFamily="34" charset="0"/>
+                <a:ea typeface="Tahoma" panose="020B0604030504040204" pitchFamily="34" charset="-122"/>
+                <a:cs typeface="Tahoma" panose="020B0604030504040204" pitchFamily="34" charset="-120"/>
               </a:rPr>
               <a:t>ไม่ใช่ฟลุก และ AI เล็งช่วงปลอดภัยไม่ได้</a:t>
             </a:r>
@@ -4225,7 +4081,7 @@
       </p:sp>
       <p:pic>
         <p:nvPicPr>
-          <p:cNvPr id="5" name="Image 0" descr="C:\artificial-evolution\reports\figures\toxin_learner_comparison.png">    </p:cNvPr>
+          <p:cNvPr id="5" name="Image 0" descr="C:\artificial-evolution\reports\figures\toxin_learner_comparison.png"/>
           <p:cNvPicPr>
             <a:picLocks noChangeAspect="1"/>
           </p:cNvPicPr>
@@ -4233,8 +4089,10 @@
         </p:nvPicPr>
         <p:blipFill>
           <a:blip r:embed="rId1"/>
-          <a:srcRect l="0" r="0" t="0" b="0"/>
-          <a:stretch/>
+          <a:srcRect/>
+          <a:stretch>
+            <a:fillRect/>
+          </a:stretch>
         </p:blipFill>
         <p:spPr>
           <a:xfrm>
@@ -4245,7 +4103,7 @@
             <a:avLst/>
           </a:prstGeom>
           <a:effectLst>
-            <a:outerShdw sx="100000" sy="100000" kx="0" ky="0" algn="bl" rotWithShape="0" blurRad="76200" dist="25400" dir="5400000">
+            <a:outerShdw blurRad="76200" dist="25400" dir="5400000" algn="bl" rotWithShape="0">
               <a:srgbClr val="9AA6A2">
                 <a:alpha val="35000"/>
               </a:srgbClr>
@@ -4272,9 +4130,8 @@
           <a:solidFill>
             <a:srgbClr val="EAF3EF"/>
           </a:solidFill>
-          <a:ln/>
           <a:effectLst>
-            <a:outerShdw sx="100000" sy="100000" kx="0" ky="0" algn="bl" rotWithShape="0" blurRad="76200" dist="25400" dir="5400000">
+            <a:outerShdw blurRad="76200" dist="25400" dir="5400000" algn="bl" rotWithShape="0">
               <a:srgbClr val="9AA6A2">
                 <a:alpha val="35000"/>
               </a:srgbClr>
@@ -4297,13 +4154,12 @@
             <a:avLst/>
           </a:prstGeom>
           <a:noFill/>
-          <a:ln/>
         </p:spPr>
         <p:txBody>
           <a:bodyPr wrap="square" lIns="0" tIns="0" rIns="0" bIns="0" rtlCol="0" anchor="ctr"/>
           <a:lstStyle/>
           <a:p>
-            <a:pPr algn="ctr" indent="0" marL="0">
+            <a:pPr marL="0" indent="0" algn="ctr">
               <a:buNone/>
             </a:pPr>
             <a:r>
@@ -4311,9 +4167,9 @@
                 <a:solidFill>
                   <a:srgbClr val="0F6E56"/>
                 </a:solidFill>
-                <a:latin typeface="Tahoma" pitchFamily="34" charset="0"/>
-                <a:ea typeface="Tahoma" pitchFamily="34" charset="-122"/>
-                <a:cs typeface="Tahoma" pitchFamily="34" charset="-120"/>
+                <a:latin typeface="Tahoma" panose="020B0604030504040204" pitchFamily="34" charset="0"/>
+                <a:ea typeface="Tahoma" panose="020B0604030504040204" pitchFamily="34" charset="-122"/>
+                <a:cs typeface="Tahoma" panose="020B0604030504040204" pitchFamily="34" charset="-120"/>
               </a:rPr>
               <a:t>×4</a:t>
             </a:r>
@@ -4336,13 +4192,12 @@
             <a:avLst/>
           </a:prstGeom>
           <a:noFill/>
-          <a:ln/>
         </p:spPr>
         <p:txBody>
           <a:bodyPr wrap="square" lIns="0" tIns="0" rIns="0" bIns="0" rtlCol="0" anchor="t"/>
           <a:lstStyle/>
           <a:p>
-            <a:pPr algn="ctr" indent="0" marL="0">
+            <a:pPr marL="0" indent="0" algn="ctr">
               <a:buNone/>
             </a:pPr>
             <a:r>
@@ -4350,9 +4205,9 @@
                 <a:solidFill>
                   <a:srgbClr val="22302E"/>
                 </a:solidFill>
-                <a:latin typeface="Tahoma" pitchFamily="34" charset="0"/>
-                <a:ea typeface="Tahoma" pitchFamily="34" charset="-122"/>
-                <a:cs typeface="Tahoma" pitchFamily="34" charset="-120"/>
+                <a:latin typeface="Tahoma" panose="020B0604030504040204" pitchFamily="34" charset="0"/>
+                <a:ea typeface="Tahoma" panose="020B0604030504040204" pitchFamily="34" charset="-122"/>
+                <a:cs typeface="Tahoma" panose="020B0604030504040204" pitchFamily="34" charset="-120"/>
               </a:rPr>
               <a:t>กฎการเรียนรู้มาตรฐานที่ทดสอบ — ถูกหลอกทุกแบบ</a:t>
             </a:r>
@@ -4379,9 +4234,8 @@
           <a:solidFill>
             <a:srgbClr val="F7E9E7"/>
           </a:solidFill>
-          <a:ln/>
           <a:effectLst>
-            <a:outerShdw sx="100000" sy="100000" kx="0" ky="0" algn="bl" rotWithShape="0" blurRad="76200" dist="25400" dir="5400000">
+            <a:outerShdw blurRad="76200" dist="25400" dir="5400000" algn="bl" rotWithShape="0">
               <a:srgbClr val="9AA6A2">
                 <a:alpha val="35000"/>
               </a:srgbClr>
@@ -4404,13 +4258,12 @@
             <a:avLst/>
           </a:prstGeom>
           <a:noFill/>
-          <a:ln/>
         </p:spPr>
         <p:txBody>
           <a:bodyPr wrap="square" lIns="0" tIns="0" rIns="0" bIns="0" rtlCol="0" anchor="ctr"/>
           <a:lstStyle/>
           <a:p>
-            <a:pPr algn="ctr" indent="0" marL="0">
+            <a:pPr marL="0" indent="0" algn="ctr">
               <a:buNone/>
             </a:pPr>
             <a:r>
@@ -4418,9 +4271,9 @@
                 <a:solidFill>
                   <a:srgbClr val="B2352E"/>
                 </a:solidFill>
-                <a:latin typeface="Tahoma" pitchFamily="34" charset="0"/>
-                <a:ea typeface="Tahoma" pitchFamily="34" charset="-122"/>
-                <a:cs typeface="Tahoma" pitchFamily="34" charset="-120"/>
+                <a:latin typeface="Tahoma" panose="020B0604030504040204" pitchFamily="34" charset="0"/>
+                <a:ea typeface="Tahoma" panose="020B0604030504040204" pitchFamily="34" charset="-122"/>
+                <a:cs typeface="Tahoma" panose="020B0604030504040204" pitchFamily="34" charset="-120"/>
               </a:rPr>
               <a:t>0%</a:t>
             </a:r>
@@ -4443,13 +4296,12 @@
             <a:avLst/>
           </a:prstGeom>
           <a:noFill/>
-          <a:ln/>
         </p:spPr>
         <p:txBody>
           <a:bodyPr wrap="square" lIns="0" tIns="0" rIns="0" bIns="0" rtlCol="0" anchor="t"/>
           <a:lstStyle/>
           <a:p>
-            <a:pPr algn="ctr" indent="0" marL="0">
+            <a:pPr marL="0" indent="0" algn="ctr">
               <a:buNone/>
             </a:pPr>
             <a:r>
@@ -4457,9 +4309,9 @@
                 <a:solidFill>
                   <a:srgbClr val="22302E"/>
                 </a:solidFill>
-                <a:latin typeface="Tahoma" pitchFamily="34" charset="0"/>
-                <a:ea typeface="Tahoma" pitchFamily="34" charset="-122"/>
-                <a:cs typeface="Tahoma" pitchFamily="34" charset="-120"/>
+                <a:latin typeface="Tahoma" panose="020B0604030504040204" pitchFamily="34" charset="0"/>
+                <a:ea typeface="Tahoma" panose="020B0604030504040204" pitchFamily="34" charset="-122"/>
+                <a:cs typeface="Tahoma" panose="020B0604030504040204" pitchFamily="34" charset="-120"/>
               </a:rPr>
               <a:t>แยก "ช่วงปลอดภัย" ของพิษไม่โมโนโทนิกไม่ได้เลย</a:t>
             </a:r>
@@ -4469,7 +4321,7 @@
       </p:sp>
       <p:pic>
         <p:nvPicPr>
-          <p:cNvPr id="12" name="Image 1" descr="C:\artificial-evolution\reports\figures\toxin_window_sim_result.png">    </p:cNvPr>
+          <p:cNvPr id="12" name="Image 1" descr="C:\artificial-evolution\reports\figures\toxin_window_sim_result.png"/>
           <p:cNvPicPr>
             <a:picLocks noChangeAspect="1"/>
           </p:cNvPicPr>
@@ -4477,8 +4329,10 @@
         </p:nvPicPr>
         <p:blipFill>
           <a:blip r:embed="rId2"/>
-          <a:srcRect l="0" r="0" t="0" b="0"/>
-          <a:stretch/>
+          <a:srcRect/>
+          <a:stretch>
+            <a:fillRect/>
+          </a:stretch>
         </p:blipFill>
         <p:spPr>
           <a:xfrm>
@@ -4489,7 +4343,7 @@
             <a:avLst/>
           </a:prstGeom>
           <a:effectLst>
-            <a:outerShdw sx="100000" sy="100000" kx="0" ky="0" algn="bl" rotWithShape="0" blurRad="76200" dist="25400" dir="5400000">
+            <a:outerShdw blurRad="76200" dist="25400" dir="5400000" algn="bl" rotWithShape="0">
               <a:srgbClr val="9AA6A2">
                 <a:alpha val="35000"/>
               </a:srgbClr>
@@ -4507,7 +4361,7 @@
 
 <file path=ppt/slides/slide8.xml><?xml version="1.0" encoding="utf-8"?>
 <p:sld xmlns:a="http://schemas.openxmlformats.org/drawingml/2006/main" xmlns:r="http://schemas.openxmlformats.org/officeDocument/2006/relationships" xmlns:p="http://schemas.openxmlformats.org/presentationml/2006/main">
-  <p:cSld name="Slide 8">
+  <p:cSld>
     <p:spTree>
       <p:nvGrpSpPr>
         <p:cNvPr id="1" name=""/>
@@ -4539,7 +4393,6 @@
           <a:solidFill>
             <a:srgbClr val="0F6E56"/>
           </a:solidFill>
-          <a:ln/>
         </p:spPr>
       </p:sp>
       <p:sp>
@@ -4557,13 +4410,12 @@
             <a:avLst/>
           </a:prstGeom>
           <a:noFill/>
-          <a:ln/>
         </p:spPr>
         <p:txBody>
           <a:bodyPr wrap="square" lIns="0" tIns="0" rIns="0" bIns="0" rtlCol="0" anchor="ctr"/>
           <a:lstStyle/>
           <a:p>
-            <a:pPr algn="ctr" indent="0" marL="0">
+            <a:pPr marL="0" indent="0" algn="ctr">
               <a:buNone/>
             </a:pPr>
             <a:r>
@@ -4571,9 +4423,9 @@
                 <a:solidFill>
                   <a:srgbClr val="FFFFFF"/>
                 </a:solidFill>
-                <a:latin typeface="Tahoma" pitchFamily="34" charset="0"/>
-                <a:ea typeface="Tahoma" pitchFamily="34" charset="-122"/>
-                <a:cs typeface="Tahoma" pitchFamily="34" charset="-120"/>
+                <a:latin typeface="Tahoma" panose="020B0604030504040204" pitchFamily="34" charset="0"/>
+                <a:ea typeface="Tahoma" panose="020B0604030504040204" pitchFamily="34" charset="-122"/>
+                <a:cs typeface="Tahoma" panose="020B0604030504040204" pitchFamily="34" charset="-120"/>
               </a:rPr>
               <a:t>7</a:t>
             </a:r>
@@ -4596,13 +4448,12 @@
             <a:avLst/>
           </a:prstGeom>
           <a:noFill/>
-          <a:ln/>
         </p:spPr>
         <p:txBody>
           <a:bodyPr wrap="square" lIns="0" tIns="0" rIns="0" bIns="0" rtlCol="0" anchor="ctr"/>
           <a:lstStyle/>
           <a:p>
-            <a:pPr algn="l" indent="0" marL="0">
+            <a:pPr marL="0" indent="0" algn="l">
               <a:buNone/>
             </a:pPr>
             <a:r>
@@ -4610,9 +4461,9 @@
                 <a:solidFill>
                   <a:srgbClr val="22302E"/>
                 </a:solidFill>
-                <a:latin typeface="Tahoma" pitchFamily="34" charset="0"/>
-                <a:ea typeface="Tahoma" pitchFamily="34" charset="-122"/>
-                <a:cs typeface="Tahoma" pitchFamily="34" charset="-120"/>
+                <a:latin typeface="Tahoma" panose="020B0604030504040204" pitchFamily="34" charset="0"/>
+                <a:ea typeface="Tahoma" panose="020B0604030504040204" pitchFamily="34" charset="-122"/>
+                <a:cs typeface="Tahoma" panose="020B0604030504040204" pitchFamily="34" charset="-120"/>
               </a:rPr>
               <a:t>ทำไมสำคัญ: หลักการความปลอดภัย AI</a:t>
             </a:r>
@@ -4639,9 +4490,8 @@
           <a:solidFill>
             <a:srgbClr val="0F6E56"/>
           </a:solidFill>
-          <a:ln/>
           <a:effectLst>
-            <a:outerShdw sx="100000" sy="100000" kx="0" ky="0" algn="bl" rotWithShape="0" blurRad="76200" dist="25400" dir="5400000">
+            <a:outerShdw blurRad="76200" dist="25400" dir="5400000" algn="bl" rotWithShape="0">
               <a:srgbClr val="9AA6A2">
                 <a:alpha val="35000"/>
               </a:srgbClr>
@@ -4664,13 +4514,12 @@
             <a:avLst/>
           </a:prstGeom>
           <a:noFill/>
-          <a:ln/>
         </p:spPr>
         <p:txBody>
           <a:bodyPr wrap="square" lIns="0" tIns="0" rIns="0" bIns="0" rtlCol="0" anchor="ctr"/>
           <a:lstStyle/>
           <a:p>
-            <a:pPr algn="l" indent="0" marL="0">
+            <a:pPr marL="0" indent="0" algn="l">
               <a:buNone/>
             </a:pPr>
             <a:r>
@@ -4678,9 +4527,9 @@
                 <a:solidFill>
                   <a:srgbClr val="FFFFFF"/>
                 </a:solidFill>
-                <a:latin typeface="Tahoma" pitchFamily="34" charset="0"/>
-                <a:ea typeface="Tahoma" pitchFamily="34" charset="-122"/>
-                <a:cs typeface="Tahoma" pitchFamily="34" charset="-120"/>
+                <a:latin typeface="Tahoma" panose="020B0604030504040204" pitchFamily="34" charset="0"/>
+                <a:ea typeface="Tahoma" panose="020B0604030504040204" pitchFamily="34" charset="-122"/>
+                <a:cs typeface="Tahoma" panose="020B0604030504040204" pitchFamily="34" charset="-120"/>
               </a:rPr>
               <a:t>AI ที่ตัดสินจาก "ชนิด" ของสิ่งของ จะพลาดเมื่ออันตรายขึ้นกับ "สภาพ" (อายุ/เวลา) ที่มองไม่เห็น</a:t>
             </a:r>
@@ -4707,9 +4556,8 @@
           <a:solidFill>
             <a:srgbClr val="EAF3EF"/>
           </a:solidFill>
-          <a:ln/>
           <a:effectLst>
-            <a:outerShdw sx="100000" sy="100000" kx="0" ky="0" algn="bl" rotWithShape="0" blurRad="76200" dist="25400" dir="5400000">
+            <a:outerShdw blurRad="76200" dist="25400" dir="5400000" algn="bl" rotWithShape="0">
               <a:srgbClr val="9AA6A2">
                 <a:alpha val="35000"/>
               </a:srgbClr>
@@ -4734,7 +4582,6 @@
           <a:solidFill>
             <a:srgbClr val="0F6E56"/>
           </a:solidFill>
-          <a:ln/>
         </p:spPr>
       </p:sp>
       <p:sp>
@@ -4752,13 +4599,12 @@
             <a:avLst/>
           </a:prstGeom>
           <a:noFill/>
-          <a:ln/>
         </p:spPr>
         <p:txBody>
           <a:bodyPr wrap="square" lIns="0" tIns="0" rIns="0" bIns="0" rtlCol="0" anchor="ctr"/>
           <a:lstStyle/>
           <a:p>
-            <a:pPr algn="ctr" indent="0" marL="0">
+            <a:pPr marL="0" indent="0" algn="ctr">
               <a:buNone/>
             </a:pPr>
             <a:r>
@@ -4766,9 +4612,9 @@
                 <a:solidFill>
                   <a:srgbClr val="FFFFFF"/>
                 </a:solidFill>
-                <a:latin typeface="Tahoma" pitchFamily="34" charset="0"/>
-                <a:ea typeface="Tahoma" pitchFamily="34" charset="-122"/>
-                <a:cs typeface="Tahoma" pitchFamily="34" charset="-120"/>
+                <a:latin typeface="Tahoma" panose="020B0604030504040204" pitchFamily="34" charset="0"/>
+                <a:ea typeface="Tahoma" panose="020B0604030504040204" pitchFamily="34" charset="-122"/>
+                <a:cs typeface="Tahoma" panose="020B0604030504040204" pitchFamily="34" charset="-120"/>
               </a:rPr>
               <a:t>1</a:t>
             </a:r>
@@ -4791,13 +4637,12 @@
             <a:avLst/>
           </a:prstGeom>
           <a:noFill/>
-          <a:ln/>
         </p:spPr>
         <p:txBody>
           <a:bodyPr wrap="square" lIns="0" tIns="0" rIns="0" bIns="0" rtlCol="0" anchor="t"/>
           <a:lstStyle/>
           <a:p>
-            <a:pPr algn="l" indent="0" marL="0">
+            <a:pPr marL="0" indent="0" algn="l">
               <a:spcAft>
                 <a:spcPts val="800"/>
               </a:spcAft>
@@ -4808,16 +4653,16 @@
                 <a:solidFill>
                   <a:srgbClr val="22302E"/>
                 </a:solidFill>
-                <a:latin typeface="Tahoma" pitchFamily="34" charset="0"/>
-                <a:ea typeface="Tahoma" pitchFamily="34" charset="-122"/>
-                <a:cs typeface="Tahoma" pitchFamily="34" charset="-120"/>
+                <a:latin typeface="Tahoma" panose="020B0604030504040204" pitchFamily="34" charset="0"/>
+                <a:ea typeface="Tahoma" panose="020B0604030504040204" pitchFamily="34" charset="-122"/>
+                <a:cs typeface="Tahoma" panose="020B0604030504040204" pitchFamily="34" charset="-120"/>
               </a:rPr>
               <a:t>เห็ดพิษ / อาหารหมักดอง</a:t>
             </a:r>
             <a:endParaRPr lang="en-US" sz="1600" dirty="0"/>
           </a:p>
           <a:p>
-            <a:pPr algn="l" indent="0" marL="0">
+            <a:pPr marL="0" indent="0" algn="l">
               <a:buNone/>
             </a:pPr>
             <a:r>
@@ -4825,9 +4670,9 @@
                 <a:solidFill>
                   <a:srgbClr val="6A7B77"/>
                 </a:solidFill>
-                <a:latin typeface="Tahoma" pitchFamily="34" charset="0"/>
-                <a:ea typeface="Tahoma" pitchFamily="34" charset="-122"/>
-                <a:cs typeface="Tahoma" pitchFamily="34" charset="-120"/>
+                <a:latin typeface="Tahoma" panose="020B0604030504040204" pitchFamily="34" charset="0"/>
+                <a:ea typeface="Tahoma" panose="020B0604030504040204" pitchFamily="34" charset="-122"/>
+                <a:cs typeface="Tahoma" panose="020B0604030504040204" pitchFamily="34" charset="-120"/>
               </a:rPr>
               <a:t>ระบบเตือนภัยที่เรียนแบบ "ค่าเฉลี่ย" อาจตัดสินผิดด้วยกลไก lure เดียวกัน</a:t>
             </a:r>
@@ -4854,9 +4699,8 @@
           <a:solidFill>
             <a:srgbClr val="EAF3EF"/>
           </a:solidFill>
-          <a:ln/>
           <a:effectLst>
-            <a:outerShdw sx="100000" sy="100000" kx="0" ky="0" algn="bl" rotWithShape="0" blurRad="76200" dist="25400" dir="5400000">
+            <a:outerShdw blurRad="76200" dist="25400" dir="5400000" algn="bl" rotWithShape="0">
               <a:srgbClr val="9AA6A2">
                 <a:alpha val="35000"/>
               </a:srgbClr>
@@ -4881,7 +4725,6 @@
           <a:solidFill>
             <a:srgbClr val="0F6E56"/>
           </a:solidFill>
-          <a:ln/>
         </p:spPr>
       </p:sp>
       <p:sp>
@@ -4899,13 +4742,12 @@
             <a:avLst/>
           </a:prstGeom>
           <a:noFill/>
-          <a:ln/>
         </p:spPr>
         <p:txBody>
           <a:bodyPr wrap="square" lIns="0" tIns="0" rIns="0" bIns="0" rtlCol="0" anchor="ctr"/>
           <a:lstStyle/>
           <a:p>
-            <a:pPr algn="ctr" indent="0" marL="0">
+            <a:pPr marL="0" indent="0" algn="ctr">
               <a:buNone/>
             </a:pPr>
             <a:r>
@@ -4913,9 +4755,9 @@
                 <a:solidFill>
                   <a:srgbClr val="FFFFFF"/>
                 </a:solidFill>
-                <a:latin typeface="Tahoma" pitchFamily="34" charset="0"/>
-                <a:ea typeface="Tahoma" pitchFamily="34" charset="-122"/>
-                <a:cs typeface="Tahoma" pitchFamily="34" charset="-120"/>
+                <a:latin typeface="Tahoma" panose="020B0604030504040204" pitchFamily="34" charset="0"/>
+                <a:ea typeface="Tahoma" panose="020B0604030504040204" pitchFamily="34" charset="-122"/>
+                <a:cs typeface="Tahoma" panose="020B0604030504040204" pitchFamily="34" charset="-120"/>
               </a:rPr>
               <a:t>2</a:t>
             </a:r>
@@ -4938,13 +4780,12 @@
             <a:avLst/>
           </a:prstGeom>
           <a:noFill/>
-          <a:ln/>
         </p:spPr>
         <p:txBody>
           <a:bodyPr wrap="square" lIns="0" tIns="0" rIns="0" bIns="0" rtlCol="0" anchor="t"/>
           <a:lstStyle/>
           <a:p>
-            <a:pPr algn="l" indent="0" marL="0">
+            <a:pPr marL="0" indent="0" algn="l">
               <a:spcAft>
                 <a:spcPts val="800"/>
               </a:spcAft>
@@ -4955,16 +4796,16 @@
                 <a:solidFill>
                   <a:srgbClr val="22302E"/>
                 </a:solidFill>
-                <a:latin typeface="Tahoma" pitchFamily="34" charset="0"/>
-                <a:ea typeface="Tahoma" pitchFamily="34" charset="-122"/>
-                <a:cs typeface="Tahoma" pitchFamily="34" charset="-120"/>
+                <a:latin typeface="Tahoma" panose="020B0604030504040204" pitchFamily="34" charset="0"/>
+                <a:ea typeface="Tahoma" panose="020B0604030504040204" pitchFamily="34" charset="-122"/>
+                <a:cs typeface="Tahoma" panose="020B0604030504040204" pitchFamily="34" charset="-120"/>
               </a:rPr>
               <a:t>หุ่นยนต์กู้ภัย/สำรวจ</a:t>
             </a:r>
             <a:endParaRPr lang="en-US" sz="1600" dirty="0"/>
           </a:p>
           <a:p>
-            <a:pPr algn="l" indent="0" marL="0">
+            <a:pPr marL="0" indent="0" algn="l">
               <a:buNone/>
             </a:pPr>
             <a:r>
@@ -4972,9 +4813,9 @@
                 <a:solidFill>
                   <a:srgbClr val="6A7B77"/>
                 </a:solidFill>
-                <a:latin typeface="Tahoma" pitchFamily="34" charset="0"/>
-                <a:ea typeface="Tahoma" pitchFamily="34" charset="-122"/>
-                <a:cs typeface="Tahoma" pitchFamily="34" charset="-120"/>
+                <a:latin typeface="Tahoma" panose="020B0604030504040204" pitchFamily="34" charset="0"/>
+                <a:ea typeface="Tahoma" panose="020B0604030504040204" pitchFamily="34" charset="-122"/>
+                <a:cs typeface="Tahoma" panose="020B0604030504040204" pitchFamily="34" charset="-120"/>
               </a:rPr>
               <a:t>ต้องตัดสินความปลอดภัยเองในที่ที่อันตรายโผล่เป็นช่วง ๆ</a:t>
             </a:r>
@@ -5001,9 +4842,8 @@
           <a:solidFill>
             <a:srgbClr val="EAF3EF"/>
           </a:solidFill>
-          <a:ln/>
           <a:effectLst>
-            <a:outerShdw sx="100000" sy="100000" kx="0" ky="0" algn="bl" rotWithShape="0" blurRad="76200" dist="25400" dir="5400000">
+            <a:outerShdw blurRad="76200" dist="25400" dir="5400000" algn="bl" rotWithShape="0">
               <a:srgbClr val="9AA6A2">
                 <a:alpha val="35000"/>
               </a:srgbClr>
@@ -5028,7 +4868,6 @@
           <a:solidFill>
             <a:srgbClr val="0F6E56"/>
           </a:solidFill>
-          <a:ln/>
         </p:spPr>
       </p:sp>
       <p:sp>
@@ -5046,13 +4885,12 @@
             <a:avLst/>
           </a:prstGeom>
           <a:noFill/>
-          <a:ln/>
         </p:spPr>
         <p:txBody>
           <a:bodyPr wrap="square" lIns="0" tIns="0" rIns="0" bIns="0" rtlCol="0" anchor="ctr"/>
           <a:lstStyle/>
           <a:p>
-            <a:pPr algn="ctr" indent="0" marL="0">
+            <a:pPr marL="0" indent="0" algn="ctr">
               <a:buNone/>
             </a:pPr>
             <a:r>
@@ -5060,9 +4898,9 @@
                 <a:solidFill>
                   <a:srgbClr val="FFFFFF"/>
                 </a:solidFill>
-                <a:latin typeface="Tahoma" pitchFamily="34" charset="0"/>
-                <a:ea typeface="Tahoma" pitchFamily="34" charset="-122"/>
-                <a:cs typeface="Tahoma" pitchFamily="34" charset="-120"/>
+                <a:latin typeface="Tahoma" panose="020B0604030504040204" pitchFamily="34" charset="0"/>
+                <a:ea typeface="Tahoma" panose="020B0604030504040204" pitchFamily="34" charset="-122"/>
+                <a:cs typeface="Tahoma" panose="020B0604030504040204" pitchFamily="34" charset="-120"/>
               </a:rPr>
               <a:t>3</a:t>
             </a:r>
@@ -5085,13 +4923,12 @@
             <a:avLst/>
           </a:prstGeom>
           <a:noFill/>
-          <a:ln/>
         </p:spPr>
         <p:txBody>
           <a:bodyPr wrap="square" lIns="0" tIns="0" rIns="0" bIns="0" rtlCol="0" anchor="t"/>
           <a:lstStyle/>
           <a:p>
-            <a:pPr algn="l" indent="0" marL="0">
+            <a:pPr marL="0" indent="0" algn="l">
               <a:spcAft>
                 <a:spcPts val="800"/>
               </a:spcAft>
@@ -5102,16 +4939,16 @@
                 <a:solidFill>
                   <a:srgbClr val="22302E"/>
                 </a:solidFill>
-                <a:latin typeface="Tahoma" pitchFamily="34" charset="0"/>
-                <a:ea typeface="Tahoma" pitchFamily="34" charset="-122"/>
-                <a:cs typeface="Tahoma" pitchFamily="34" charset="-120"/>
+                <a:latin typeface="Tahoma" panose="020B0604030504040204" pitchFamily="34" charset="0"/>
+                <a:ea typeface="Tahoma" panose="020B0604030504040204" pitchFamily="34" charset="-122"/>
+                <a:cs typeface="Tahoma" panose="020B0604030504040204" pitchFamily="34" charset="-120"/>
               </a:rPr>
               <a:t>บทเรียนออกแบบ AI</a:t>
             </a:r>
             <a:endParaRPr lang="en-US" sz="1600" dirty="0"/>
           </a:p>
           <a:p>
-            <a:pPr algn="l" indent="0" marL="0">
+            <a:pPr marL="0" indent="0" algn="l">
               <a:buNone/>
             </a:pPr>
             <a:r>
@@ -5119,9 +4956,9 @@
                 <a:solidFill>
                   <a:srgbClr val="6A7B77"/>
                 </a:solidFill>
-                <a:latin typeface="Tahoma" pitchFamily="34" charset="0"/>
-                <a:ea typeface="Tahoma" pitchFamily="34" charset="-122"/>
-                <a:cs typeface="Tahoma" pitchFamily="34" charset="-120"/>
+                <a:latin typeface="Tahoma" panose="020B0604030504040204" pitchFamily="34" charset="0"/>
+                <a:ea typeface="Tahoma" panose="020B0604030504040204" pitchFamily="34" charset="-122"/>
+                <a:cs typeface="Tahoma" panose="020B0604030504040204" pitchFamily="34" charset="-120"/>
               </a:rPr>
               <a:t>ต้องให้ AI รับรู้ "สภาพ/อายุ" ไม่ใช่แค่ "ชนิด"</a:t>
             </a:r>
@@ -5139,7 +4976,7 @@
 
 <file path=ppt/slides/slide9.xml><?xml version="1.0" encoding="utf-8"?>
 <p:sld xmlns:a="http://schemas.openxmlformats.org/drawingml/2006/main" xmlns:r="http://schemas.openxmlformats.org/officeDocument/2006/relationships" xmlns:p="http://schemas.openxmlformats.org/presentationml/2006/main">
-  <p:cSld name="Slide 9">
+  <p:cSld>
     <p:spTree>
       <p:nvGrpSpPr>
         <p:cNvPr id="1" name=""/>
@@ -5171,7 +5008,6 @@
           <a:solidFill>
             <a:srgbClr val="0F6E56"/>
           </a:solidFill>
-          <a:ln/>
         </p:spPr>
       </p:sp>
       <p:sp>
@@ -5189,13 +5025,12 @@
             <a:avLst/>
           </a:prstGeom>
           <a:noFill/>
-          <a:ln/>
         </p:spPr>
         <p:txBody>
           <a:bodyPr wrap="square" lIns="0" tIns="0" rIns="0" bIns="0" rtlCol="0" anchor="ctr"/>
           <a:lstStyle/>
           <a:p>
-            <a:pPr algn="ctr" indent="0" marL="0">
+            <a:pPr marL="0" indent="0" algn="ctr">
               <a:buNone/>
             </a:pPr>
             <a:r>
@@ -5203,9 +5038,9 @@
                 <a:solidFill>
                   <a:srgbClr val="FFFFFF"/>
                 </a:solidFill>
-                <a:latin typeface="Tahoma" pitchFamily="34" charset="0"/>
-                <a:ea typeface="Tahoma" pitchFamily="34" charset="-122"/>
-                <a:cs typeface="Tahoma" pitchFamily="34" charset="-120"/>
+                <a:latin typeface="Tahoma" panose="020B0604030504040204" pitchFamily="34" charset="0"/>
+                <a:ea typeface="Tahoma" panose="020B0604030504040204" pitchFamily="34" charset="-122"/>
+                <a:cs typeface="Tahoma" panose="020B0604030504040204" pitchFamily="34" charset="-120"/>
               </a:rPr>
               <a:t>8</a:t>
             </a:r>
@@ -5228,13 +5063,12 @@
             <a:avLst/>
           </a:prstGeom>
           <a:noFill/>
-          <a:ln/>
         </p:spPr>
         <p:txBody>
           <a:bodyPr wrap="square" lIns="0" tIns="0" rIns="0" bIns="0" rtlCol="0" anchor="ctr"/>
           <a:lstStyle/>
           <a:p>
-            <a:pPr algn="l" indent="0" marL="0">
+            <a:pPr marL="0" indent="0" algn="l">
               <a:buNone/>
             </a:pPr>
             <a:r>
@@ -5242,9 +5076,9 @@
                 <a:solidFill>
                   <a:srgbClr val="22302E"/>
                 </a:solidFill>
-                <a:latin typeface="Tahoma" pitchFamily="34" charset="0"/>
-                <a:ea typeface="Tahoma" pitchFamily="34" charset="-122"/>
-                <a:cs typeface="Tahoma" pitchFamily="34" charset="-120"/>
+                <a:latin typeface="Tahoma" panose="020B0604030504040204" pitchFamily="34" charset="0"/>
+                <a:ea typeface="Tahoma" panose="020B0604030504040204" pitchFamily="34" charset="-122"/>
+                <a:cs typeface="Tahoma" panose="020B0604030504040204" pitchFamily="34" charset="-120"/>
               </a:rPr>
               <a:t>ความซื่อสัตย์: อ้างได้ vs ยังไม่ควรอ้าง</a:t>
             </a:r>
@@ -5271,9 +5105,8 @@
           <a:solidFill>
             <a:srgbClr val="EAF3EF"/>
           </a:solidFill>
-          <a:ln/>
           <a:effectLst>
-            <a:outerShdw sx="100000" sy="100000" kx="0" ky="0" algn="bl" rotWithShape="0" blurRad="76200" dist="25400" dir="5400000">
+            <a:outerShdw blurRad="76200" dist="25400" dir="5400000" algn="bl" rotWithShape="0">
               <a:srgbClr val="9AA6A2">
                 <a:alpha val="35000"/>
               </a:srgbClr>
@@ -5296,13 +5129,12 @@
             <a:avLst/>
           </a:prstGeom>
           <a:noFill/>
-          <a:ln/>
         </p:spPr>
         <p:txBody>
           <a:bodyPr wrap="square" lIns="0" tIns="0" rIns="0" bIns="0" rtlCol="0" anchor="ctr"/>
           <a:lstStyle/>
           <a:p>
-            <a:pPr algn="l" indent="0" marL="0">
+            <a:pPr marL="0" indent="0" algn="l">
               <a:buNone/>
             </a:pPr>
             <a:r>
@@ -5310,9 +5142,9 @@
                 <a:solidFill>
                   <a:srgbClr val="0F6E56"/>
                 </a:solidFill>
-                <a:latin typeface="Tahoma" pitchFamily="34" charset="0"/>
-                <a:ea typeface="Tahoma" pitchFamily="34" charset="-122"/>
-                <a:cs typeface="Tahoma" pitchFamily="34" charset="-120"/>
+                <a:latin typeface="Tahoma" panose="020B0604030504040204" pitchFamily="34" charset="0"/>
+                <a:ea typeface="Tahoma" panose="020B0604030504040204" pitchFamily="34" charset="-122"/>
+                <a:cs typeface="Tahoma" panose="020B0604030504040204" pitchFamily="34" charset="-120"/>
               </a:rPr>
               <a:t>✓ อ้างได้ (พิสูจน์แล้ว)</a:t>
             </a:r>
@@ -5335,13 +5167,12 @@
             <a:avLst/>
           </a:prstGeom>
           <a:noFill/>
-          <a:ln/>
         </p:spPr>
         <p:txBody>
           <a:bodyPr wrap="square" lIns="0" tIns="0" rIns="0" bIns="0" rtlCol="0" anchor="t"/>
           <a:lstStyle/>
           <a:p>
-            <a:pPr algn="l" marL="177800" indent="-177800">
+            <a:pPr marL="177800" indent="-177800" algn="l">
               <a:spcAft>
                 <a:spcPts val="800"/>
               </a:spcAft>
@@ -5353,16 +5184,16 @@
                 <a:solidFill>
                   <a:srgbClr val="22302E"/>
                 </a:solidFill>
-                <a:latin typeface="Tahoma" pitchFamily="34" charset="0"/>
-                <a:ea typeface="Tahoma" pitchFamily="34" charset="-122"/>
-                <a:cs typeface="Tahoma" pitchFamily="34" charset="-120"/>
+                <a:latin typeface="Tahoma" panose="020B0604030504040204" pitchFamily="34" charset="0"/>
+                <a:ea typeface="Tahoma" panose="020B0604030504040204" pitchFamily="34" charset="-122"/>
+                <a:cs typeface="Tahoma" panose="020B0604030504040204" pitchFamily="34" charset="-120"/>
               </a:rPr>
               <a:t>AI เรียนเลือกอาหารคุ้มค่า/เลี่ยงพิษคงที่ได้เอง (หลายซีด + control)</a:t>
             </a:r>
             <a:endParaRPr lang="en-US" sz="1500" dirty="0"/>
           </a:p>
           <a:p>
-            <a:pPr algn="l" marL="177800" indent="-177800">
+            <a:pPr marL="177800" indent="-177800" algn="l">
               <a:spcAft>
                 <a:spcPts val="800"/>
               </a:spcAft>
@@ -5374,16 +5205,16 @@
                 <a:solidFill>
                   <a:srgbClr val="22302E"/>
                 </a:solidFill>
-                <a:latin typeface="Tahoma" pitchFamily="34" charset="0"/>
-                <a:ea typeface="Tahoma" pitchFamily="34" charset="-122"/>
-                <a:cs typeface="Tahoma" pitchFamily="34" charset="-120"/>
+                <a:latin typeface="Tahoma" panose="020B0604030504040204" pitchFamily="34" charset="0"/>
+                <a:ea typeface="Tahoma" panose="020B0604030504040204" pitchFamily="34" charset="-122"/>
+                <a:cs typeface="Tahoma" panose="020B0604030504040204" pitchFamily="34" charset="-120"/>
               </a:rPr>
               <a:t>การเรียนต่อชนิดถูกล่อโดยพิษที่หายได้ — ทั่วไปข้ามกฎ 4 แบบ</a:t>
             </a:r>
             <a:endParaRPr lang="en-US" sz="1500" dirty="0"/>
           </a:p>
           <a:p>
-            <a:pPr algn="l" marL="177800" indent="-177800">
+            <a:pPr marL="177800" indent="-177800" algn="l">
               <a:spcAft>
                 <a:spcPts val="800"/>
               </a:spcAft>
@@ -5395,9 +5226,9 @@
                 <a:solidFill>
                   <a:srgbClr val="22302E"/>
                 </a:solidFill>
-                <a:latin typeface="Tahoma" pitchFamily="34" charset="0"/>
-                <a:ea typeface="Tahoma" pitchFamily="34" charset="-122"/>
-                <a:cs typeface="Tahoma" pitchFamily="34" charset="-120"/>
+                <a:latin typeface="Tahoma" panose="020B0604030504040204" pitchFamily="34" charset="0"/>
+                <a:ea typeface="Tahoma" panose="020B0604030504040204" pitchFamily="34" charset="-122"/>
+                <a:cs typeface="Tahoma" panose="020B0604030504040204" pitchFamily="34" charset="-120"/>
               </a:rPr>
               <a:t>แยกช่วงปลอดภัย = 0 เป็นผลเชิงโครงสร้าง (ไม่ขึ้นกับกฎ)</a:t>
             </a:r>
@@ -5424,9 +5255,8 @@
           <a:solidFill>
             <a:srgbClr val="F7E9E7"/>
           </a:solidFill>
-          <a:ln/>
           <a:effectLst>
-            <a:outerShdw sx="100000" sy="100000" kx="0" ky="0" algn="bl" rotWithShape="0" blurRad="76200" dist="25400" dir="5400000">
+            <a:outerShdw blurRad="76200" dist="25400" dir="5400000" algn="bl" rotWithShape="0">
               <a:srgbClr val="9AA6A2">
                 <a:alpha val="35000"/>
               </a:srgbClr>
@@ -5449,13 +5279,12 @@
             <a:avLst/>
           </a:prstGeom>
           <a:noFill/>
-          <a:ln/>
         </p:spPr>
         <p:txBody>
           <a:bodyPr wrap="square" lIns="0" tIns="0" rIns="0" bIns="0" rtlCol="0" anchor="ctr"/>
           <a:lstStyle/>
           <a:p>
-            <a:pPr algn="l" indent="0" marL="0">
+            <a:pPr marL="0" indent="0" algn="l">
               <a:buNone/>
             </a:pPr>
             <a:r>
@@ -5463,9 +5292,9 @@
                 <a:solidFill>
                   <a:srgbClr val="B2352E"/>
                 </a:solidFill>
-                <a:latin typeface="Tahoma" pitchFamily="34" charset="0"/>
-                <a:ea typeface="Tahoma" pitchFamily="34" charset="-122"/>
-                <a:cs typeface="Tahoma" pitchFamily="34" charset="-120"/>
+                <a:latin typeface="Tahoma" panose="020B0604030504040204" pitchFamily="34" charset="0"/>
+                <a:ea typeface="Tahoma" panose="020B0604030504040204" pitchFamily="34" charset="-122"/>
+                <a:cs typeface="Tahoma" panose="020B0604030504040204" pitchFamily="34" charset="-120"/>
               </a:rPr>
               <a:t>✕ ยังไม่ควรอ้าง</a:t>
             </a:r>
@@ -5488,13 +5317,12 @@
             <a:avLst/>
           </a:prstGeom>
           <a:noFill/>
-          <a:ln/>
         </p:spPr>
         <p:txBody>
           <a:bodyPr wrap="square" lIns="0" tIns="0" rIns="0" bIns="0" rtlCol="0" anchor="t"/>
           <a:lstStyle/>
           <a:p>
-            <a:pPr algn="l" marL="177800" indent="-177800">
+            <a:pPr marL="177800" indent="-177800" algn="l">
               <a:spcAft>
                 <a:spcPts val="800"/>
               </a:spcAft>
@@ -5506,16 +5334,16 @@
                 <a:solidFill>
                   <a:srgbClr val="22302E"/>
                 </a:solidFill>
-                <a:latin typeface="Tahoma" pitchFamily="34" charset="0"/>
-                <a:ea typeface="Tahoma" pitchFamily="34" charset="-122"/>
-                <a:cs typeface="Tahoma" pitchFamily="34" charset="-120"/>
+                <a:latin typeface="Tahoma" panose="020B0604030504040204" pitchFamily="34" charset="0"/>
+                <a:ea typeface="Tahoma" panose="020B0604030504040204" pitchFamily="34" charset="-122"/>
+                <a:cs typeface="Tahoma" panose="020B0604030504040204" pitchFamily="34" charset="-120"/>
               </a:rPr>
               <a:t>AI "เข้าใจ" หรือมีเจตนา/รู้คิด</a:t>
             </a:r>
             <a:endParaRPr lang="en-US" sz="1500" dirty="0"/>
           </a:p>
           <a:p>
-            <a:pPr algn="l" marL="177800" indent="-177800">
+            <a:pPr marL="177800" indent="-177800" algn="l">
               <a:spcAft>
                 <a:spcPts val="800"/>
               </a:spcAft>
@@ -5527,16 +5355,16 @@
                 <a:solidFill>
                   <a:srgbClr val="22302E"/>
                 </a:solidFill>
-                <a:latin typeface="Tahoma" pitchFamily="34" charset="0"/>
-                <a:ea typeface="Tahoma" pitchFamily="34" charset="-122"/>
-                <a:cs typeface="Tahoma" pitchFamily="34" charset="-120"/>
+                <a:latin typeface="Tahoma" panose="020B0604030504040204" pitchFamily="34" charset="0"/>
+                <a:ea typeface="Tahoma" panose="020B0604030504040204" pitchFamily="34" charset="-122"/>
+                <a:cs typeface="Tahoma" panose="020B0604030504040204" pitchFamily="34" charset="-120"/>
               </a:rPr>
               <a:t>AI วางแผน/ตั้งใจกินพิษ หรือแปรรูปอาหารได้แล้ว</a:t>
             </a:r>
             <a:endParaRPr lang="en-US" sz="1500" dirty="0"/>
           </a:p>
           <a:p>
-            <a:pPr algn="l" marL="177800" indent="-177800">
+            <a:pPr marL="177800" indent="-177800" algn="l">
               <a:spcAft>
                 <a:spcPts val="800"/>
               </a:spcAft>
@@ -5548,9 +5376,9 @@
                 <a:solidFill>
                   <a:srgbClr val="22302E"/>
                 </a:solidFill>
-                <a:latin typeface="Tahoma" pitchFamily="34" charset="0"/>
-                <a:ea typeface="Tahoma" pitchFamily="34" charset="-122"/>
-                <a:cs typeface="Tahoma" pitchFamily="34" charset="-120"/>
+                <a:latin typeface="Tahoma" panose="020B0604030504040204" pitchFamily="34" charset="0"/>
+                <a:ea typeface="Tahoma" panose="020B0604030504040204" pitchFamily="34" charset="-122"/>
+                <a:cs typeface="Tahoma" panose="020B0604030504040204" pitchFamily="34" charset="-120"/>
               </a:rPr>
               <a:t>ต้นทุนการอยู่รอดจริง — ผลนี้วัดจาก "ค่าที่รับรู้" ในสภาพควบคุม ยังไม่วัดการตายจริง</a:t>
             </a:r>
@@ -5609,7 +5437,7 @@
     </a:clrScheme>
     <a:fontScheme name="Office">
       <a:majorFont>
-        <a:latin typeface="Calibri Light" panose="020F0302020204030204"/>
+        <a:latin typeface="Calibri Light"/>
         <a:ea typeface=""/>
         <a:cs typeface=""/>
         <a:font script="Jpan" typeface="游ゴシック Light"/>
@@ -5642,26 +5470,9 @@
         <a:font script="Viet" typeface="Times New Roman"/>
         <a:font script="Uigh" typeface="Microsoft Uighur"/>
         <a:font script="Geor" typeface="Sylfaen"/>
-        <a:font script="Armn" typeface="Arial"/>
-        <a:font script="Bugi" typeface="Leelawadee UI"/>
-        <a:font script="Bopo" typeface="Microsoft JhengHei"/>
-        <a:font script="Java" typeface="Javanese Text"/>
-        <a:font script="Lisu" typeface="Segoe UI"/>
-        <a:font script="Mymr" typeface="Myanmar Text"/>
-        <a:font script="Nkoo" typeface="Ebrima"/>
-        <a:font script="Olck" typeface="Nirmala UI"/>
-        <a:font script="Osma" typeface="Ebrima"/>
-        <a:font script="Phag" typeface="Phagspa"/>
-        <a:font script="Syrn" typeface="Estrangelo Edessa"/>
-        <a:font script="Syrj" typeface="Estrangelo Edessa"/>
-        <a:font script="Syre" typeface="Estrangelo Edessa"/>
-        <a:font script="Sora" typeface="Nirmala UI"/>
-        <a:font script="Tale" typeface="Microsoft Tai Le"/>
-        <a:font script="Talu" typeface="Microsoft New Tai Lue"/>
-        <a:font script="Tfng" typeface="Ebrima"/>
       </a:majorFont>
       <a:minorFont>
-        <a:latin typeface="Calibri" panose="020F0502020204030204"/>
+        <a:latin typeface="Calibri"/>
         <a:ea typeface=""/>
         <a:cs typeface=""/>
         <a:font script="Jpan" typeface="游ゴシック"/>
@@ -5694,23 +5505,6 @@
         <a:font script="Viet" typeface="Arial"/>
         <a:font script="Uigh" typeface="Microsoft Uighur"/>
         <a:font script="Geor" typeface="Sylfaen"/>
-        <a:font script="Armn" typeface="Arial"/>
-        <a:font script="Bugi" typeface="Leelawadee UI"/>
-        <a:font script="Bopo" typeface="Microsoft JhengHei"/>
-        <a:font script="Java" typeface="Javanese Text"/>
-        <a:font script="Lisu" typeface="Segoe UI"/>
-        <a:font script="Mymr" typeface="Myanmar Text"/>
-        <a:font script="Nkoo" typeface="Ebrima"/>
-        <a:font script="Olck" typeface="Nirmala UI"/>
-        <a:font script="Osma" typeface="Ebrima"/>
-        <a:font script="Phag" typeface="Phagspa"/>
-        <a:font script="Syrn" typeface="Estrangelo Edessa"/>
-        <a:font script="Syrj" typeface="Estrangelo Edessa"/>
-        <a:font script="Syre" typeface="Estrangelo Edessa"/>
-        <a:font script="Sora" typeface="Nirmala UI"/>
-        <a:font script="Tale" typeface="Microsoft Tai Le"/>
-        <a:font script="Talu" typeface="Microsoft New Tai Lue"/>
-        <a:font script="Tfng" typeface="Ebrima"/>
       </a:minorFont>
     </a:fontScheme>
     <a:fmtScheme name="Office">
@@ -5851,8 +5645,265 @@
       </a:bgFillStyleLst>
     </a:fmtScheme>
   </a:themeElements>
-  <a:objectDefaults/>
-  <a:extraClrSchemeLst/>
+  <a:extLst>
+    <a:ext uri="{05A4C25C-085E-4340-85A3-A5531E510DB2}">
+      <thm15:themeFamily xmlns:thm15="http://schemas.microsoft.com/office/thememl/2012/main" name="Office Theme" id="{62F939B6-93AF-4DB8-9C6B-D6C7DFDC589F}" vid="{4A3C46E8-61CC-4603-A589-7422A47A8E4A}"/>
+    </a:ext>
+  </a:extLst>
+</a:theme>
+</file>
+
+<file path=ppt/theme/theme2.xml><?xml version="1.0" encoding="utf-8"?>
+<a:theme xmlns:a="http://schemas.openxmlformats.org/drawingml/2006/main" name="Office Theme">
+  <a:themeElements>
+    <a:clrScheme name="Office">
+      <a:dk1>
+        <a:sysClr val="windowText" lastClr="000000"/>
+      </a:dk1>
+      <a:lt1>
+        <a:sysClr val="window" lastClr="FFFFFF"/>
+      </a:lt1>
+      <a:dk2>
+        <a:srgbClr val="44546A"/>
+      </a:dk2>
+      <a:lt2>
+        <a:srgbClr val="E7E6E6"/>
+      </a:lt2>
+      <a:accent1>
+        <a:srgbClr val="4472C4"/>
+      </a:accent1>
+      <a:accent2>
+        <a:srgbClr val="ED7D31"/>
+      </a:accent2>
+      <a:accent3>
+        <a:srgbClr val="A5A5A5"/>
+      </a:accent3>
+      <a:accent4>
+        <a:srgbClr val="FFC000"/>
+      </a:accent4>
+      <a:accent5>
+        <a:srgbClr val="5B9BD5"/>
+      </a:accent5>
+      <a:accent6>
+        <a:srgbClr val="70AD47"/>
+      </a:accent6>
+      <a:hlink>
+        <a:srgbClr val="0563C1"/>
+      </a:hlink>
+      <a:folHlink>
+        <a:srgbClr val="954F72"/>
+      </a:folHlink>
+    </a:clrScheme>
+    <a:fontScheme name="Office">
+      <a:majorFont>
+        <a:latin typeface="Calibri Light"/>
+        <a:ea typeface=""/>
+        <a:cs typeface=""/>
+        <a:font script="Jpan" typeface="游ゴシック Light"/>
+        <a:font script="Hang" typeface="맑은 고딕"/>
+        <a:font script="Hans" typeface="等线 Light"/>
+        <a:font script="Hant" typeface="新細明體"/>
+        <a:font script="Arab" typeface="Times New Roman"/>
+        <a:font script="Hebr" typeface="Times New Roman"/>
+        <a:font script="Thai" typeface="Angsana New"/>
+        <a:font script="Ethi" typeface="Nyala"/>
+        <a:font script="Beng" typeface="Vrinda"/>
+        <a:font script="Gujr" typeface="Shruti"/>
+        <a:font script="Khmr" typeface="MoolBoran"/>
+        <a:font script="Knda" typeface="Tunga"/>
+        <a:font script="Guru" typeface="Raavi"/>
+        <a:font script="Cans" typeface="Euphemia"/>
+        <a:font script="Cher" typeface="Plantagenet Cherokee"/>
+        <a:font script="Yiii" typeface="Microsoft Yi Baiti"/>
+        <a:font script="Tibt" typeface="Microsoft Himalaya"/>
+        <a:font script="Thaa" typeface="MV Boli"/>
+        <a:font script="Deva" typeface="Mangal"/>
+        <a:font script="Telu" typeface="Gautami"/>
+        <a:font script="Taml" typeface="Latha"/>
+        <a:font script="Syrc" typeface="Estrangelo Edessa"/>
+        <a:font script="Orya" typeface="Kalinga"/>
+        <a:font script="Mlym" typeface="Kartika"/>
+        <a:font script="Laoo" typeface="DokChampa"/>
+        <a:font script="Sinh" typeface="Iskoola Pota"/>
+        <a:font script="Mong" typeface="Mongolian Baiti"/>
+        <a:font script="Viet" typeface="Times New Roman"/>
+        <a:font script="Uigh" typeface="Microsoft Uighur"/>
+        <a:font script="Geor" typeface="Sylfaen"/>
+      </a:majorFont>
+      <a:minorFont>
+        <a:latin typeface="Calibri"/>
+        <a:ea typeface=""/>
+        <a:cs typeface=""/>
+        <a:font script="Jpan" typeface="游ゴシック"/>
+        <a:font script="Hang" typeface="맑은 고딕"/>
+        <a:font script="Hans" typeface="等线"/>
+        <a:font script="Hant" typeface="新細明體"/>
+        <a:font script="Arab" typeface="Arial"/>
+        <a:font script="Hebr" typeface="Arial"/>
+        <a:font script="Thai" typeface="Cordia New"/>
+        <a:font script="Ethi" typeface="Nyala"/>
+        <a:font script="Beng" typeface="Vrinda"/>
+        <a:font script="Gujr" typeface="Shruti"/>
+        <a:font script="Khmr" typeface="DaunPenh"/>
+        <a:font script="Knda" typeface="Tunga"/>
+        <a:font script="Guru" typeface="Raavi"/>
+        <a:font script="Cans" typeface="Euphemia"/>
+        <a:font script="Cher" typeface="Plantagenet Cherokee"/>
+        <a:font script="Yiii" typeface="Microsoft Yi Baiti"/>
+        <a:font script="Tibt" typeface="Microsoft Himalaya"/>
+        <a:font script="Thaa" typeface="MV Boli"/>
+        <a:font script="Deva" typeface="Mangal"/>
+        <a:font script="Telu" typeface="Gautami"/>
+        <a:font script="Taml" typeface="Latha"/>
+        <a:font script="Syrc" typeface="Estrangelo Edessa"/>
+        <a:font script="Orya" typeface="Kalinga"/>
+        <a:font script="Mlym" typeface="Kartika"/>
+        <a:font script="Laoo" typeface="DokChampa"/>
+        <a:font script="Sinh" typeface="Iskoola Pota"/>
+        <a:font script="Mong" typeface="Mongolian Baiti"/>
+        <a:font script="Viet" typeface="Arial"/>
+        <a:font script="Uigh" typeface="Microsoft Uighur"/>
+        <a:font script="Geor" typeface="Sylfaen"/>
+      </a:minorFont>
+    </a:fontScheme>
+    <a:fmtScheme name="Office">
+      <a:fillStyleLst>
+        <a:solidFill>
+          <a:schemeClr val="phClr"/>
+        </a:solidFill>
+        <a:gradFill rotWithShape="1">
+          <a:gsLst>
+            <a:gs pos="0">
+              <a:schemeClr val="phClr">
+                <a:lumMod val="110000"/>
+                <a:satMod val="105000"/>
+                <a:tint val="67000"/>
+              </a:schemeClr>
+            </a:gs>
+            <a:gs pos="50000">
+              <a:schemeClr val="phClr">
+                <a:lumMod val="105000"/>
+                <a:satMod val="103000"/>
+                <a:tint val="73000"/>
+              </a:schemeClr>
+            </a:gs>
+            <a:gs pos="100000">
+              <a:schemeClr val="phClr">
+                <a:lumMod val="105000"/>
+                <a:satMod val="109000"/>
+                <a:tint val="81000"/>
+              </a:schemeClr>
+            </a:gs>
+          </a:gsLst>
+          <a:lin ang="5400000" scaled="0"/>
+        </a:gradFill>
+        <a:gradFill rotWithShape="1">
+          <a:gsLst>
+            <a:gs pos="0">
+              <a:schemeClr val="phClr">
+                <a:satMod val="103000"/>
+                <a:lumMod val="102000"/>
+                <a:tint val="94000"/>
+              </a:schemeClr>
+            </a:gs>
+            <a:gs pos="50000">
+              <a:schemeClr val="phClr">
+                <a:satMod val="110000"/>
+                <a:lumMod val="100000"/>
+                <a:shade val="100000"/>
+              </a:schemeClr>
+            </a:gs>
+            <a:gs pos="100000">
+              <a:schemeClr val="phClr">
+                <a:lumMod val="99000"/>
+                <a:satMod val="120000"/>
+                <a:shade val="78000"/>
+              </a:schemeClr>
+            </a:gs>
+          </a:gsLst>
+          <a:lin ang="5400000" scaled="0"/>
+        </a:gradFill>
+      </a:fillStyleLst>
+      <a:lnStyleLst>
+        <a:ln w="6350" cap="flat" cmpd="sng" algn="ctr">
+          <a:solidFill>
+            <a:schemeClr val="phClr"/>
+          </a:solidFill>
+          <a:prstDash val="solid"/>
+          <a:miter lim="800000"/>
+        </a:ln>
+        <a:ln w="12700" cap="flat" cmpd="sng" algn="ctr">
+          <a:solidFill>
+            <a:schemeClr val="phClr"/>
+          </a:solidFill>
+          <a:prstDash val="solid"/>
+          <a:miter lim="800000"/>
+        </a:ln>
+        <a:ln w="19050" cap="flat" cmpd="sng" algn="ctr">
+          <a:solidFill>
+            <a:schemeClr val="phClr"/>
+          </a:solidFill>
+          <a:prstDash val="solid"/>
+          <a:miter lim="800000"/>
+        </a:ln>
+      </a:lnStyleLst>
+      <a:effectStyleLst>
+        <a:effectStyle>
+          <a:effectLst/>
+        </a:effectStyle>
+        <a:effectStyle>
+          <a:effectLst/>
+        </a:effectStyle>
+        <a:effectStyle>
+          <a:effectLst>
+            <a:outerShdw blurRad="57150" dist="19050" dir="5400000" algn="ctr" rotWithShape="0">
+              <a:srgbClr val="000000">
+                <a:alpha val="63000"/>
+              </a:srgbClr>
+            </a:outerShdw>
+          </a:effectLst>
+        </a:effectStyle>
+      </a:effectStyleLst>
+      <a:bgFillStyleLst>
+        <a:solidFill>
+          <a:schemeClr val="phClr"/>
+        </a:solidFill>
+        <a:solidFill>
+          <a:schemeClr val="phClr">
+            <a:tint val="95000"/>
+            <a:satMod val="170000"/>
+          </a:schemeClr>
+        </a:solidFill>
+        <a:gradFill rotWithShape="1">
+          <a:gsLst>
+            <a:gs pos="0">
+              <a:schemeClr val="phClr">
+                <a:tint val="93000"/>
+                <a:satMod val="150000"/>
+                <a:shade val="98000"/>
+                <a:lumMod val="102000"/>
+              </a:schemeClr>
+            </a:gs>
+            <a:gs pos="50000">
+              <a:schemeClr val="phClr">
+                <a:tint val="98000"/>
+                <a:satMod val="130000"/>
+                <a:shade val="90000"/>
+                <a:lumMod val="103000"/>
+              </a:schemeClr>
+            </a:gs>
+            <a:gs pos="100000">
+              <a:schemeClr val="phClr">
+                <a:shade val="63000"/>
+                <a:satMod val="120000"/>
+              </a:schemeClr>
+            </a:gs>
+          </a:gsLst>
+          <a:lin ang="5400000" scaled="0"/>
+        </a:gradFill>
+      </a:bgFillStyleLst>
+    </a:fmtScheme>
+  </a:themeElements>
   <a:extLst>
     <a:ext uri="{05A4C25C-085E-4340-85A3-A5531E510DB2}">
       <thm15:themeFamily xmlns:thm15="http://schemas.microsoft.com/office/thememl/2012/main" name="Office Theme" id="{62F939B6-93AF-4DB8-9C6B-D6C7DFDC589F}" vid="{4A3C46E8-61CC-4603-A589-7422A47A8E4A}"/>

</xml_diff>